<commit_message>
feat: update slides with latest production performance metrics and premium UI control options
Co-authored-by: Cursor <cursoragent@cursor.com>
</commit_message>
<xml_diff>
--- a/presentation_slides.pptx
+++ b/presentation_slides.pptx
@@ -12,6 +12,7 @@
     <p:sldId id="260" r:id="rId11"/>
     <p:sldId id="261" r:id="rId12"/>
     <p:sldId id="262" r:id="rId13"/>
+    <p:sldId id="263" r:id="rId14"/>
   </p:sldIdLst>
   <p:sldSz cx="12191695" cy="6858000" type="screen4x3"/>
   <p:notesSz cx="6858000" cy="9144000"/>
@@ -5693,6 +5694,443 @@
     <p:bg>
       <p:bgPr>
         <a:solidFill>
+          <a:srgbClr val="FFFFFF"/>
+        </a:solidFill>
+        <a:effectLst/>
+      </p:bgPr>
+    </p:bg>
+    <p:spTree>
+      <p:nvGrpSpPr>
+        <p:cNvPr id="1" name=""/>
+        <p:cNvGrpSpPr/>
+        <p:nvPr/>
+      </p:nvGrpSpPr>
+      <p:grpSpPr/>
+      <p:sp>
+        <p:nvSpPr>
+          <p:cNvPr id="2" name="TextBox 1"/>
+          <p:cNvSpPr txBox="1"/>
+          <p:nvPr/>
+        </p:nvSpPr>
+        <p:spPr>
+          <a:xfrm>
+            <a:off x="685800" y="274320"/>
+            <a:ext cx="10820095" cy="274320"/>
+          </a:xfrm>
+          <a:prstGeom prst="rect">
+            <a:avLst/>
+          </a:prstGeom>
+          <a:noFill/>
+        </p:spPr>
+        <p:txBody>
+          <a:bodyPr wrap="square" tIns="0" bIns="0" lIns="0">
+            <a:spAutoFit/>
+          </a:bodyPr>
+          <a:lstStyle/>
+          <a:p>
+            <a:pPr>
+              <a:defRPr sz="1000" b="1">
+                <a:solidFill>
+                  <a:srgbClr val="00A8B5"/>
+                </a:solidFill>
+                <a:latin typeface="Arial"/>
+              </a:defRPr>
+            </a:pPr>
+            <a:r>
+              <a:t>VERTEX SMART CATEGORIZATION ENGINE</a:t>
+            </a:r>
+          </a:p>
+        </p:txBody>
+      </p:sp>
+      <p:sp>
+        <p:nvSpPr>
+          <p:cNvPr id="3" name="TextBox 2"/>
+          <p:cNvSpPr txBox="1"/>
+          <p:nvPr/>
+        </p:nvSpPr>
+        <p:spPr>
+          <a:xfrm>
+            <a:off x="685800" y="457200"/>
+            <a:ext cx="10820095" cy="731520"/>
+          </a:xfrm>
+          <a:prstGeom prst="rect">
+            <a:avLst/>
+          </a:prstGeom>
+          <a:noFill/>
+        </p:spPr>
+        <p:txBody>
+          <a:bodyPr wrap="square" tIns="0" bIns="0" lIns="0">
+            <a:spAutoFit/>
+          </a:bodyPr>
+          <a:lstStyle/>
+          <a:p>
+            <a:pPr>
+              <a:defRPr sz="2800" b="1">
+                <a:solidFill>
+                  <a:srgbClr val="0A2240"/>
+                </a:solidFill>
+                <a:latin typeface="Arial"/>
+              </a:defRPr>
+            </a:pPr>
+            <a:r>
+              <a:t>Latest Production Performance &amp; UI Dashboard</a:t>
+            </a:r>
+          </a:p>
+        </p:txBody>
+      </p:sp>
+      <p:sp>
+        <p:nvSpPr>
+          <p:cNvPr id="4" name="Rectangle 3"/>
+          <p:cNvSpPr/>
+          <p:nvPr/>
+        </p:nvSpPr>
+        <p:spPr>
+          <a:xfrm>
+            <a:off x="685800" y="1188720"/>
+            <a:ext cx="1828800" cy="36576"/>
+          </a:xfrm>
+          <a:prstGeom prst="rect">
+            <a:avLst/>
+          </a:prstGeom>
+          <a:solidFill>
+            <a:srgbClr val="00A8B5"/>
+          </a:solidFill>
+          <a:ln>
+            <a:noFill/>
+          </a:ln>
+        </p:spPr>
+        <p:style>
+          <a:lnRef idx="1">
+            <a:schemeClr val="accent1"/>
+          </a:lnRef>
+          <a:fillRef idx="3">
+            <a:schemeClr val="accent1"/>
+          </a:fillRef>
+          <a:effectRef idx="2">
+            <a:schemeClr val="accent1"/>
+          </a:effectRef>
+          <a:fontRef idx="minor">
+            <a:schemeClr val="lt1"/>
+          </a:fontRef>
+        </p:style>
+        <p:txBody>
+          <a:bodyPr rtlCol="0" anchor="ctr"/>
+          <a:lstStyle/>
+          <a:p>
+            <a:pPr algn="ctr"/>
+          </a:p>
+        </p:txBody>
+      </p:sp>
+      <p:sp>
+        <p:nvSpPr>
+          <p:cNvPr id="5" name="Rounded Rectangle 4"/>
+          <p:cNvSpPr/>
+          <p:nvPr/>
+        </p:nvSpPr>
+        <p:spPr>
+          <a:xfrm>
+            <a:off x="685800" y="1463040"/>
+            <a:ext cx="5120640" cy="4754880"/>
+          </a:xfrm>
+          <a:prstGeom prst="roundRect">
+            <a:avLst/>
+          </a:prstGeom>
+          <a:solidFill>
+            <a:srgbClr val="F0F9FA"/>
+          </a:solidFill>
+          <a:ln w="19050">
+            <a:solidFill>
+              <a:srgbClr val="00A8B5"/>
+            </a:solidFill>
+          </a:ln>
+        </p:spPr>
+        <p:style>
+          <a:lnRef idx="1">
+            <a:schemeClr val="accent1"/>
+          </a:lnRef>
+          <a:fillRef idx="3">
+            <a:schemeClr val="accent1"/>
+          </a:fillRef>
+          <a:effectRef idx="2">
+            <a:schemeClr val="accent1"/>
+          </a:effectRef>
+          <a:fontRef idx="minor">
+            <a:schemeClr val="lt1"/>
+          </a:fontRef>
+        </p:style>
+        <p:txBody>
+          <a:bodyPr rtlCol="0" anchor="ctr"/>
+          <a:lstStyle/>
+          <a:p>
+            <a:pPr algn="ctr"/>
+          </a:p>
+        </p:txBody>
+      </p:sp>
+      <p:sp>
+        <p:nvSpPr>
+          <p:cNvPr id="6" name="TextBox 5"/>
+          <p:cNvSpPr txBox="1"/>
+          <p:nvPr/>
+        </p:nvSpPr>
+        <p:spPr>
+          <a:xfrm>
+            <a:off x="868680" y="1645920"/>
+            <a:ext cx="4754880" cy="4389120"/>
+          </a:xfrm>
+          <a:prstGeom prst="rect">
+            <a:avLst/>
+          </a:prstGeom>
+          <a:noFill/>
+        </p:spPr>
+        <p:txBody>
+          <a:bodyPr wrap="square">
+            <a:spAutoFit/>
+          </a:bodyPr>
+          <a:lstStyle/>
+          <a:p>
+            <a:pPr>
+              <a:spcAft>
+                <a:spcPts val="1000"/>
+              </a:spcAft>
+              <a:defRPr sz="1300" b="1">
+                <a:solidFill>
+                  <a:srgbClr val="0A2240"/>
+                </a:solidFill>
+                <a:latin typeface="Arial"/>
+              </a:defRPr>
+            </a:pPr>
+            <a:r>
+              <a:t>REAL-WORLD BENCHMARKS (50 PRODUCTS)</a:t>
+            </a:r>
+          </a:p>
+          <a:p>
+            <a:pPr>
+              <a:defRPr b="1" sz="1350">
+                <a:solidFill>
+                  <a:srgbClr val="0A2240"/>
+                </a:solidFill>
+              </a:defRPr>
+            </a:pPr>
+            <a:r>
+              <a:t>🎯 Micro Precision: 91.36%</a:t>
+            </a:r>
+          </a:p>
+          <a:p>
+            <a:pPr>
+              <a:spcAft>
+                <a:spcPts val="800"/>
+              </a:spcAft>
+              <a:defRPr sz="1100">
+                <a:solidFill>
+                  <a:srgbClr val="5A6473"/>
+                </a:solidFill>
+              </a:defRPr>
+            </a:pPr>
+            <a:r>
+              <a:t>Ensures robust tax audit compliance by successfully filtering false product matches out of downstream datasets.</a:t>
+            </a:r>
+          </a:p>
+          <a:p>
+            <a:pPr>
+              <a:defRPr b="1" sz="1350">
+                <a:solidFill>
+                  <a:srgbClr val="00A8B5"/>
+                </a:solidFill>
+              </a:defRPr>
+            </a:pPr>
+            <a:r>
+              <a:t>⭐ F0.5 Score (Primary Metric): 83.24%</a:t>
+            </a:r>
+          </a:p>
+          <a:p>
+            <a:pPr>
+              <a:spcAft>
+                <a:spcPts val="800"/>
+              </a:spcAft>
+              <a:defRPr sz="1100">
+                <a:solidFill>
+                  <a:srgbClr val="5A6473"/>
+                </a:solidFill>
+              </a:defRPr>
+            </a:pPr>
+            <a:r>
+              <a:t>F1 metric score is 73.45% (with 61.41% Recall). High F0.5 weighting confirms our pipeline is mathematically tuned for accuracy over volume.</a:t>
+            </a:r>
+          </a:p>
+          <a:p>
+            <a:pPr>
+              <a:defRPr b="1" sz="1350">
+                <a:solidFill>
+                  <a:srgbClr val="212529"/>
+                </a:solidFill>
+              </a:defRPr>
+            </a:pPr>
+            <a:r>
+              <a:t>⚡ Speed &amp; Cost-Efficiency</a:t>
+            </a:r>
+          </a:p>
+          <a:p>
+            <a:pPr>
+              <a:defRPr sz="1100">
+                <a:solidFill>
+                  <a:srgbClr val="5A6473"/>
+                </a:solidFill>
+              </a:defRPr>
+            </a:pPr>
+            <a:r>
+              <a:t>• Execution Time: 29.54s (~0.59s per product via ThreadPools)</a:t>
+            </a:r>
+            <a:br/>
+            <a:r>
+              <a:t>• Estimated Run Cost: $0.0268 total (~$5.36 per 10k products)</a:t>
+            </a:r>
+          </a:p>
+        </p:txBody>
+      </p:sp>
+      <p:sp>
+        <p:nvSpPr>
+          <p:cNvPr id="7" name="Rounded Rectangle 6"/>
+          <p:cNvSpPr/>
+          <p:nvPr/>
+        </p:nvSpPr>
+        <p:spPr>
+          <a:xfrm>
+            <a:off x="6385255" y="1463040"/>
+            <a:ext cx="5120640" cy="4754880"/>
+          </a:xfrm>
+          <a:prstGeom prst="roundRect">
+            <a:avLst/>
+          </a:prstGeom>
+          <a:solidFill>
+            <a:srgbClr val="F5F7FA"/>
+          </a:solidFill>
+          <a:ln w="12700">
+            <a:solidFill>
+              <a:srgbClr val="DCE1E6"/>
+            </a:solidFill>
+          </a:ln>
+        </p:spPr>
+        <p:style>
+          <a:lnRef idx="1">
+            <a:schemeClr val="accent1"/>
+          </a:lnRef>
+          <a:fillRef idx="3">
+            <a:schemeClr val="accent1"/>
+          </a:fillRef>
+          <a:effectRef idx="2">
+            <a:schemeClr val="accent1"/>
+          </a:effectRef>
+          <a:fontRef idx="minor">
+            <a:schemeClr val="lt1"/>
+          </a:fontRef>
+        </p:style>
+        <p:txBody>
+          <a:bodyPr rtlCol="0" anchor="ctr"/>
+          <a:lstStyle/>
+          <a:p>
+            <a:pPr algn="ctr"/>
+          </a:p>
+        </p:txBody>
+      </p:sp>
+      <p:sp>
+        <p:nvSpPr>
+          <p:cNvPr id="8" name="TextBox 7"/>
+          <p:cNvSpPr txBox="1"/>
+          <p:nvPr/>
+        </p:nvSpPr>
+        <p:spPr>
+          <a:xfrm>
+            <a:off x="6568135" y="1645920"/>
+            <a:ext cx="4754880" cy="4389120"/>
+          </a:xfrm>
+          <a:prstGeom prst="rect">
+            <a:avLst/>
+          </a:prstGeom>
+          <a:noFill/>
+        </p:spPr>
+        <p:txBody>
+          <a:bodyPr wrap="square">
+            <a:spAutoFit/>
+          </a:bodyPr>
+          <a:lstStyle/>
+          <a:p>
+            <a:pPr>
+              <a:spcAft>
+                <a:spcPts val="1000"/>
+              </a:spcAft>
+              <a:defRPr sz="1300" b="1">
+                <a:solidFill>
+                  <a:srgbClr val="0A2240"/>
+                </a:solidFill>
+                <a:latin typeface="Arial"/>
+              </a:defRPr>
+            </a:pPr>
+            <a:r>
+              <a:t>PREMIUM TUI CONTROL DASHBOARD</a:t>
+            </a:r>
+          </a:p>
+          <a:p>
+            <a:pPr>
+              <a:spcAft>
+                <a:spcPts val="800"/>
+              </a:spcAft>
+              <a:defRPr sz="1100">
+                <a:solidFill>
+                  <a:srgbClr val="5A6473"/>
+                </a:solidFill>
+              </a:defRPr>
+            </a:pPr>
+            <a:r>
+              <a:t>A professional, 10-option interactive bash console (menu.sh) handles complex AI operations in a user-friendly CLI:</a:t>
+            </a:r>
+          </a:p>
+          <a:p>
+            <a:pPr>
+              <a:lnSpc>
+                <a:spcPct val="115000"/>
+              </a:lnSpc>
+              <a:defRPr sz="1100">
+                <a:solidFill>
+                  <a:srgbClr val="212529"/>
+                </a:solidFill>
+              </a:defRPr>
+            </a:pPr>
+            <a:r>
+              <a:t>• [1-3] Operational Pipelines: Run mock baselines or parallel OpenAI threads on custom product datasets.</a:t>
+            </a:r>
+            <a:br/>
+            <a:r>
+              <a:t>• [4] Auto-Prompt Optimizer: Self-tuning loop to dynamically fix prompt instructions based on failure sets.</a:t>
+            </a:r>
+            <a:br/>
+            <a:r>
+              <a:t>• [5] Visual side-by-side Prompt Diff: Instantly review optimized vs baseline guidelines via diff_prompts.py.</a:t>
+            </a:r>
+            <a:br/>
+            <a:r>
+              <a:t>• [6-7] Presentations &amp; Reports: Auto-generate visual browser dashboards (training_runs_report.md) &amp; slides.</a:t>
+            </a:r>
+            <a:br/>
+            <a:r>
+              <a:t>• [9] Saved Pipeline Summaries: Quickly fetch local summaries (evaluation_report_summary.txt).</a:t>
+            </a:r>
+          </a:p>
+        </p:txBody>
+      </p:sp>
+    </p:spTree>
+  </p:cSld>
+  <p:clrMapOvr>
+    <a:masterClrMapping/>
+  </p:clrMapOvr>
+</p:sld>
+</file>
+
+<file path=ppt/slides/slide8.xml><?xml version="1.0" encoding="utf-8"?>
+<p:sld xmlns:a="http://schemas.openxmlformats.org/drawingml/2006/main" xmlns:p="http://schemas.openxmlformats.org/presentationml/2006/main" xmlns:r="http://schemas.openxmlformats.org/officeDocument/2006/relationships">
+  <p:cSld>
+    <p:bg>
+      <p:bgPr>
+        <a:solidFill>
           <a:srgbClr val="0A2240"/>
         </a:solidFill>
         <a:effectLst/>
@@ -5969,7 +6407,7 @@
               </a:defRPr>
             </a:pPr>
             <a:r>
-              <a:t>GPT-4o-mini achieves &gt;92% Precision and &gt;88% F1-score with optimized, structured prompt rules.</a:t>
+              <a:t>GPT-4o-mini achieves &gt;91.36% Precision and &gt;83% precision-weighted F0.5-score with optimized, structured prompt rules.</a:t>
             </a:r>
           </a:p>
           <a:p>
@@ -6020,7 +6458,7 @@
               </a:defRPr>
             </a:pPr>
             <a:r>
-              <a:t>Extremely affordable run costs: ~$0.02 per 100 products ($20.00 total for 100k products).</a:t>
+              <a:t>Extremely affordable run costs: ~$0.05 per 100 products ($50.00 total for 100k products).</a:t>
             </a:r>
           </a:p>
         </p:txBody>
@@ -6131,7 +6569,7 @@
               </a:defRPr>
             </a:pPr>
             <a:r>
-              <a:t>Evaluation harness, smart offline baseline, parallelized OpenAI Structured Output API, and self-improving prompt optimization loop.</a:t>
+              <a:t>Evaluation harness, smart offline baseline, parallelized SOTA OpenAI Structured Output API, and self-improving prompt optimization loop.</a:t>
             </a:r>
           </a:p>
           <a:p>

</xml_diff>

<commit_message>
feat: add test dataset/predictions and simplify slides (remove emojis, clean human typography)
Co-authored-by: Cursor <cursoragent@cursor.com>
</commit_message>
<xml_diff>
--- a/presentation_slides.pptx
+++ b/presentation_slides.pptx
@@ -3091,7 +3091,7 @@
     <p:bg>
       <p:bgPr>
         <a:solidFill>
-          <a:srgbClr val="0A2240"/>
+          <a:srgbClr val="FFFFFF"/>
         </a:solidFill>
         <a:effectLst/>
       </p:bgPr>
@@ -3105,23 +3105,145 @@
       <p:grpSpPr/>
       <p:sp>
         <p:nvSpPr>
-          <p:cNvPr id="2" name="Right Triangle 1"/>
+          <p:cNvPr id="2" name="TextBox 1"/>
+          <p:cNvSpPr txBox="1"/>
+          <p:nvPr/>
+        </p:nvSpPr>
+        <p:spPr>
+          <a:xfrm>
+            <a:off x="914400" y="1645920"/>
+            <a:ext cx="10362895" cy="2286000"/>
+          </a:xfrm>
+          <a:prstGeom prst="rect">
+            <a:avLst/>
+          </a:prstGeom>
+          <a:noFill/>
+        </p:spPr>
+        <p:txBody>
+          <a:bodyPr wrap="square" tIns="0" lIns="0">
+            <a:spAutoFit/>
+          </a:bodyPr>
+          <a:lstStyle/>
+          <a:p>
+            <a:pPr>
+              <a:spcAft>
+                <a:spcPts val="1200"/>
+              </a:spcAft>
+              <a:defRPr sz="4600" b="1">
+                <a:solidFill>
+                  <a:srgbClr val="0F2043"/>
+                </a:solidFill>
+                <a:latin typeface="Calibri"/>
+              </a:defRPr>
+            </a:pPr>
+            <a:r>
+              <a:t>Smart Categorization Engine</a:t>
+            </a:r>
+          </a:p>
+          <a:p>
+            <a:pPr>
+              <a:defRPr sz="2000">
+                <a:solidFill>
+                  <a:srgbClr val="007382"/>
+                </a:solidFill>
+                <a:latin typeface="Calibri"/>
+              </a:defRPr>
+            </a:pPr>
+            <a:r>
+              <a:t>Building a High-Precision, Self-Improving LLM Pipeline for Tax-Compliant Product Matching</a:t>
+            </a:r>
+          </a:p>
+        </p:txBody>
+      </p:sp>
+      <p:sp>
+        <p:nvSpPr>
+          <p:cNvPr id="3" name="TextBox 2"/>
+          <p:cNvSpPr txBox="1"/>
+          <p:nvPr/>
+        </p:nvSpPr>
+        <p:spPr>
+          <a:xfrm>
+            <a:off x="914400" y="4114800"/>
+            <a:ext cx="4572000" cy="1828800"/>
+          </a:xfrm>
+          <a:prstGeom prst="rect">
+            <a:avLst/>
+          </a:prstGeom>
+          <a:noFill/>
+        </p:spPr>
+        <p:txBody>
+          <a:bodyPr wrap="square" tIns="0" lIns="0">
+            <a:spAutoFit/>
+          </a:bodyPr>
+          <a:lstStyle/>
+          <a:p>
+            <a:pPr>
+              <a:spcAft>
+                <a:spcPts val="600"/>
+              </a:spcAft>
+              <a:defRPr sz="1500" b="1">
+                <a:solidFill>
+                  <a:srgbClr val="282D34"/>
+                </a:solidFill>
+                <a:latin typeface="Calibri"/>
+              </a:defRPr>
+            </a:pPr>
+            <a:r>
+              <a:t>Presenter: Lead AI Product Engineer</a:t>
+            </a:r>
+          </a:p>
+          <a:p>
+            <a:pPr>
+              <a:spcAft>
+                <a:spcPts val="600"/>
+              </a:spcAft>
+              <a:defRPr sz="1400">
+                <a:solidFill>
+                  <a:srgbClr val="646973"/>
+                </a:solidFill>
+                <a:latin typeface="Calibri"/>
+              </a:defRPr>
+            </a:pPr>
+            <a:r>
+              <a:t>Date: September 2026</a:t>
+            </a:r>
+          </a:p>
+          <a:p>
+            <a:pPr>
+              <a:defRPr sz="1300">
+                <a:solidFill>
+                  <a:srgbClr val="007382"/>
+                </a:solidFill>
+                <a:latin typeface="Calibri"/>
+              </a:defRPr>
+            </a:pPr>
+            <a:r>
+              <a:t>Repository: github.com/rahiakil/tkhome</a:t>
+            </a:r>
+          </a:p>
+        </p:txBody>
+      </p:sp>
+      <p:sp>
+        <p:nvSpPr>
+          <p:cNvPr id="4" name="Rounded Rectangle 3"/>
           <p:cNvSpPr/>
           <p:nvPr/>
         </p:nvSpPr>
         <p:spPr>
-          <a:xfrm rot="10800000">
-            <a:off x="8686800" y="0"/>
-            <a:ext cx="3504895" cy="6858000"/>
-          </a:xfrm>
-          <a:prstGeom prst="rtTriangle">
+          <a:xfrm>
+            <a:off x="6217920" y="3931920"/>
+            <a:ext cx="5029200" cy="2011680"/>
+          </a:xfrm>
+          <a:prstGeom prst="roundRect">
             <a:avLst/>
           </a:prstGeom>
           <a:solidFill>
-            <a:srgbClr val="0C2A4E"/>
+            <a:srgbClr val="F8F9FC"/>
           </a:solidFill>
-          <a:ln>
-            <a:noFill/>
+          <a:ln w="12700">
+            <a:solidFill>
+              <a:srgbClr val="E1E4EB"/>
+            </a:solidFill>
           </a:ln>
         </p:spPr>
         <p:style>
@@ -3148,57 +3270,14 @@
       </p:sp>
       <p:sp>
         <p:nvSpPr>
-          <p:cNvPr id="3" name="Rectangle 2"/>
-          <p:cNvSpPr/>
-          <p:nvPr/>
-        </p:nvSpPr>
-        <p:spPr>
-          <a:xfrm>
-            <a:off x="0" y="0"/>
-            <a:ext cx="137160" cy="6858000"/>
-          </a:xfrm>
-          <a:prstGeom prst="rect">
-            <a:avLst/>
-          </a:prstGeom>
-          <a:solidFill>
-            <a:srgbClr val="00A8B5"/>
-          </a:solidFill>
-          <a:ln>
-            <a:noFill/>
-          </a:ln>
-        </p:spPr>
-        <p:style>
-          <a:lnRef idx="1">
-            <a:schemeClr val="accent1"/>
-          </a:lnRef>
-          <a:fillRef idx="3">
-            <a:schemeClr val="accent1"/>
-          </a:fillRef>
-          <a:effectRef idx="2">
-            <a:schemeClr val="accent1"/>
-          </a:effectRef>
-          <a:fontRef idx="minor">
-            <a:schemeClr val="lt1"/>
-          </a:fontRef>
-        </p:style>
-        <p:txBody>
-          <a:bodyPr rtlCol="0" anchor="ctr"/>
-          <a:lstStyle/>
-          <a:p>
-            <a:pPr algn="ctr"/>
-          </a:p>
-        </p:txBody>
-      </p:sp>
-      <p:sp>
-        <p:nvSpPr>
-          <p:cNvPr id="4" name="TextBox 3"/>
+          <p:cNvPr id="5" name="TextBox 4"/>
           <p:cNvSpPr txBox="1"/>
           <p:nvPr/>
         </p:nvSpPr>
         <p:spPr>
           <a:xfrm>
-            <a:off x="914400" y="1463040"/>
-            <a:ext cx="10362895" cy="2011680"/>
+            <a:off x="6400800" y="4114800"/>
+            <a:ext cx="4663440" cy="1645920"/>
           </a:xfrm>
           <a:prstGeom prst="rect">
             <a:avLst/>
@@ -3206,171 +3285,6 @@
           <a:noFill/>
         </p:spPr>
         <p:txBody>
-          <a:bodyPr wrap="square" tIns="0" lIns="0">
-            <a:spAutoFit/>
-          </a:bodyPr>
-          <a:lstStyle/>
-          <a:p>
-            <a:pPr>
-              <a:spcAft>
-                <a:spcPts val="1000"/>
-              </a:spcAft>
-              <a:defRPr sz="4400" b="1">
-                <a:solidFill>
-                  <a:srgbClr val="FFFFFF"/>
-                </a:solidFill>
-                <a:latin typeface="Arial"/>
-              </a:defRPr>
-            </a:pPr>
-            <a:r>
-              <a:t>Smart Categorization Engine</a:t>
-            </a:r>
-          </a:p>
-          <a:p>
-            <a:pPr>
-              <a:defRPr sz="1800">
-                <a:solidFill>
-                  <a:srgbClr val="00A8B5"/>
-                </a:solidFill>
-                <a:latin typeface="Arial"/>
-              </a:defRPr>
-            </a:pPr>
-            <a:r>
-              <a:t>Building a High-Precision, Self-Improving LLM Pipeline for Tax-Compliant Product Matching</a:t>
-            </a:r>
-          </a:p>
-        </p:txBody>
-      </p:sp>
-      <p:sp>
-        <p:nvSpPr>
-          <p:cNvPr id="5" name="TextBox 4"/>
-          <p:cNvSpPr txBox="1"/>
-          <p:nvPr/>
-        </p:nvSpPr>
-        <p:spPr>
-          <a:xfrm>
-            <a:off x="914400" y="3840480"/>
-            <a:ext cx="4572000" cy="1828800"/>
-          </a:xfrm>
-          <a:prstGeom prst="rect">
-            <a:avLst/>
-          </a:prstGeom>
-          <a:noFill/>
-        </p:spPr>
-        <p:txBody>
-          <a:bodyPr wrap="square" tIns="0" lIns="0">
-            <a:spAutoFit/>
-          </a:bodyPr>
-          <a:lstStyle/>
-          <a:p>
-            <a:pPr>
-              <a:spcAft>
-                <a:spcPts val="600"/>
-              </a:spcAft>
-              <a:defRPr sz="1400">
-                <a:solidFill>
-                  <a:srgbClr val="FFFFFF"/>
-                </a:solidFill>
-                <a:latin typeface="Arial"/>
-              </a:defRPr>
-            </a:pPr>
-            <a:r>
-              <a:t>Presenter: Lead AI Product Engineer</a:t>
-            </a:r>
-          </a:p>
-          <a:p>
-            <a:pPr>
-              <a:spcAft>
-                <a:spcPts val="600"/>
-              </a:spcAft>
-              <a:defRPr sz="1300">
-                <a:solidFill>
-                  <a:srgbClr val="AAB9CD"/>
-                </a:solidFill>
-                <a:latin typeface="Arial"/>
-              </a:defRPr>
-            </a:pPr>
-            <a:r>
-              <a:t>Date: September 2026</a:t>
-            </a:r>
-          </a:p>
-          <a:p>
-            <a:pPr>
-              <a:defRPr sz="1200">
-                <a:solidFill>
-                  <a:srgbClr val="00A8B5"/>
-                </a:solidFill>
-                <a:latin typeface="Arial"/>
-              </a:defRPr>
-            </a:pPr>
-            <a:r>
-              <a:t>Repository: https://github.com/rahiakil/tkhome</a:t>
-            </a:r>
-          </a:p>
-        </p:txBody>
-      </p:sp>
-      <p:sp>
-        <p:nvSpPr>
-          <p:cNvPr id="6" name="Rounded Rectangle 5"/>
-          <p:cNvSpPr/>
-          <p:nvPr/>
-        </p:nvSpPr>
-        <p:spPr>
-          <a:xfrm>
-            <a:off x="5943600" y="3657600"/>
-            <a:ext cx="5303520" cy="2194560"/>
-          </a:xfrm>
-          <a:prstGeom prst="roundRect">
-            <a:avLst/>
-          </a:prstGeom>
-          <a:solidFill>
-            <a:srgbClr val="14325A"/>
-          </a:solidFill>
-          <a:ln w="19050">
-            <a:solidFill>
-              <a:srgbClr val="00A8B5"/>
-            </a:solidFill>
-          </a:ln>
-        </p:spPr>
-        <p:style>
-          <a:lnRef idx="1">
-            <a:schemeClr val="accent1"/>
-          </a:lnRef>
-          <a:fillRef idx="3">
-            <a:schemeClr val="accent1"/>
-          </a:fillRef>
-          <a:effectRef idx="2">
-            <a:schemeClr val="accent1"/>
-          </a:effectRef>
-          <a:fontRef idx="minor">
-            <a:schemeClr val="lt1"/>
-          </a:fontRef>
-        </p:style>
-        <p:txBody>
-          <a:bodyPr rtlCol="0" anchor="ctr"/>
-          <a:lstStyle/>
-          <a:p>
-            <a:pPr algn="ctr"/>
-          </a:p>
-        </p:txBody>
-      </p:sp>
-      <p:sp>
-        <p:nvSpPr>
-          <p:cNvPr id="7" name="TextBox 6"/>
-          <p:cNvSpPr txBox="1"/>
-          <p:nvPr/>
-        </p:nvSpPr>
-        <p:spPr>
-          <a:xfrm>
-            <a:off x="6126480" y="3840480"/>
-            <a:ext cx="4937760" cy="1828800"/>
-          </a:xfrm>
-          <a:prstGeom prst="rect">
-            <a:avLst/>
-          </a:prstGeom>
-          <a:noFill/>
-        </p:spPr>
-        <p:txBody>
           <a:bodyPr wrap="square">
             <a:spAutoFit/>
           </a:bodyPr>
@@ -3380,11 +3294,11 @@
               <a:spcAft>
                 <a:spcPts val="800"/>
               </a:spcAft>
-              <a:defRPr sz="1100" b="1">
-                <a:solidFill>
-                  <a:srgbClr val="00A8B5"/>
-                </a:solidFill>
-                <a:latin typeface="Arial"/>
+              <a:defRPr sz="1200" b="1">
+                <a:solidFill>
+                  <a:srgbClr val="007382"/>
+                </a:solidFill>
+                <a:latin typeface="Calibri"/>
               </a:defRPr>
             </a:pPr>
             <a:r>
@@ -3396,11 +3310,11 @@
               <a:lnSpc>
                 <a:spcPct val="115000"/>
               </a:lnSpc>
-              <a:defRPr sz="1200">
-                <a:solidFill>
-                  <a:srgbClr val="FFFFFF"/>
-                </a:solidFill>
-                <a:latin typeface="Arial"/>
+              <a:defRPr sz="1300">
+                <a:solidFill>
+                  <a:srgbClr val="282D34"/>
+                </a:solidFill>
+                <a:latin typeface="Calibri"/>
               </a:defRPr>
             </a:pPr>
             <a:r>
@@ -3443,8 +3357,8 @@
         </p:nvSpPr>
         <p:spPr>
           <a:xfrm>
-            <a:off x="685800" y="274320"/>
-            <a:ext cx="10820095" cy="274320"/>
+            <a:off x="731520" y="365760"/>
+            <a:ext cx="10728655" cy="274320"/>
           </a:xfrm>
           <a:prstGeom prst="rect">
             <a:avLst/>
@@ -3460,9 +3374,9 @@
             <a:pPr>
               <a:defRPr sz="1000" b="1">
                 <a:solidFill>
-                  <a:srgbClr val="00A8B5"/>
-                </a:solidFill>
-                <a:latin typeface="Arial"/>
+                  <a:srgbClr val="007382"/>
+                </a:solidFill>
+                <a:latin typeface="Calibri"/>
               </a:defRPr>
             </a:pPr>
             <a:r>
@@ -3479,8 +3393,8 @@
         </p:nvSpPr>
         <p:spPr>
           <a:xfrm>
-            <a:off x="685800" y="457200"/>
-            <a:ext cx="10820095" cy="731520"/>
+            <a:off x="731520" y="594360"/>
+            <a:ext cx="10728655" cy="731520"/>
           </a:xfrm>
           <a:prstGeom prst="rect">
             <a:avLst/>
@@ -3494,11 +3408,11 @@
           <a:lstStyle/>
           <a:p>
             <a:pPr>
-              <a:defRPr sz="2800" b="1">
-                <a:solidFill>
-                  <a:srgbClr val="0A2240"/>
-                </a:solidFill>
-                <a:latin typeface="Arial"/>
+              <a:defRPr sz="3200" b="1">
+                <a:solidFill>
+                  <a:srgbClr val="0F2043"/>
+                </a:solidFill>
+                <a:latin typeface="Calibri"/>
               </a:defRPr>
             </a:pPr>
             <a:r>
@@ -3509,23 +3423,25 @@
       </p:sp>
       <p:sp>
         <p:nvSpPr>
-          <p:cNvPr id="4" name="Rectangle 3"/>
+          <p:cNvPr id="4" name="Rounded Rectangle 3"/>
           <p:cNvSpPr/>
           <p:nvPr/>
         </p:nvSpPr>
         <p:spPr>
           <a:xfrm>
-            <a:off x="685800" y="1188720"/>
-            <a:ext cx="1828800" cy="36576"/>
-          </a:xfrm>
-          <a:prstGeom prst="rect">
+            <a:off x="731520" y="1463040"/>
+            <a:ext cx="5120640" cy="3657600"/>
+          </a:xfrm>
+          <a:prstGeom prst="roundRect">
             <a:avLst/>
           </a:prstGeom>
           <a:solidFill>
-            <a:srgbClr val="00A8B5"/>
+            <a:srgbClr val="F8F9FC"/>
           </a:solidFill>
-          <a:ln>
-            <a:noFill/>
+          <a:ln w="12700">
+            <a:solidFill>
+              <a:srgbClr val="E1E4EB"/>
+            </a:solidFill>
           </a:ln>
         </p:spPr>
         <p:style>
@@ -3552,24 +3468,118 @@
       </p:sp>
       <p:sp>
         <p:nvSpPr>
-          <p:cNvPr id="5" name="Rounded Rectangle 4"/>
+          <p:cNvPr id="5" name="TextBox 4"/>
+          <p:cNvSpPr txBox="1"/>
+          <p:nvPr/>
+        </p:nvSpPr>
+        <p:spPr>
+          <a:xfrm>
+            <a:off x="914400" y="1645920"/>
+            <a:ext cx="4754880" cy="3291840"/>
+          </a:xfrm>
+          <a:prstGeom prst="rect">
+            <a:avLst/>
+          </a:prstGeom>
+          <a:noFill/>
+        </p:spPr>
+        <p:txBody>
+          <a:bodyPr wrap="square">
+            <a:spAutoFit/>
+          </a:bodyPr>
+          <a:lstStyle/>
+          <a:p>
+            <a:pPr>
+              <a:spcAft>
+                <a:spcPts val="1200"/>
+              </a:spcAft>
+              <a:defRPr sz="1300" b="1">
+                <a:solidFill>
+                  <a:srgbClr val="0F2043"/>
+                </a:solidFill>
+                <a:latin typeface="Calibri"/>
+              </a:defRPr>
+            </a:pPr>
+            <a:r>
+              <a:t>THE INFORMATION GAP</a:t>
+            </a:r>
+          </a:p>
+          <a:p>
+            <a:pPr>
+              <a:defRPr b="1" sz="1400">
+                <a:solidFill>
+                  <a:srgbClr val="282D34"/>
+                </a:solidFill>
+                <a:latin typeface="Calibri"/>
+              </a:defRPr>
+            </a:pPr>
+            <a:r>
+              <a:t>The Tax Engine Requirement</a:t>
+            </a:r>
+          </a:p>
+          <a:p>
+            <a:pPr>
+              <a:spcAft>
+                <a:spcPts val="1200"/>
+              </a:spcAft>
+              <a:defRPr sz="1300">
+                <a:solidFill>
+                  <a:srgbClr val="646973"/>
+                </a:solidFill>
+                <a:latin typeface="Calibri"/>
+              </a:defRPr>
+            </a:pPr>
+            <a:r>
+              <a:t>Vertex's tax engine (O-Series) needs extremely granular product details (ingredients, sweeteners, alcohol content, packaging format) to compute correct tax.</a:t>
+            </a:r>
+          </a:p>
+          <a:p>
+            <a:pPr>
+              <a:defRPr b="1" sz="1400">
+                <a:solidFill>
+                  <a:srgbClr val="282D34"/>
+                </a:solidFill>
+                <a:latin typeface="Calibri"/>
+              </a:defRPr>
+            </a:pPr>
+            <a:r>
+              <a:t>The Retailer Data Gap</a:t>
+            </a:r>
+          </a:p>
+          <a:p>
+            <a:pPr>
+              <a:defRPr sz="1300">
+                <a:solidFill>
+                  <a:srgbClr val="646973"/>
+                </a:solidFill>
+                <a:latin typeface="Calibri"/>
+              </a:defRPr>
+            </a:pPr>
+            <a:r>
+              <a:t>Big-box retailers rarely have this level of detail. They only provide product titles (e.g., 'Lipton CB Unswet Blk Tea 14oz') which are brief and highly abbreviated.</a:t>
+            </a:r>
+          </a:p>
+        </p:txBody>
+      </p:sp>
+      <p:sp>
+        <p:nvSpPr>
+          <p:cNvPr id="6" name="Rounded Rectangle 5"/>
           <p:cNvSpPr/>
           <p:nvPr/>
         </p:nvSpPr>
         <p:spPr>
           <a:xfrm>
-            <a:off x="685800" y="1463040"/>
-            <a:ext cx="5120640" cy="3749039"/>
+            <a:off x="6309360" y="1463040"/>
+            <a:ext cx="5120640" cy="3657600"/>
           </a:xfrm>
           <a:prstGeom prst="roundRect">
             <a:avLst/>
           </a:prstGeom>
           <a:solidFill>
-            <a:srgbClr val="F5F7FA"/>
+            <a:srgbClr val="F8F9FC"/>
           </a:solidFill>
           <a:ln w="12700">
             <a:solidFill>
-              <a:srgbClr val="DCE1E6"/>
+              <a:srgbClr val="E1E4EB"/>
             </a:solidFill>
           </a:ln>
         </p:spPr>
@@ -3597,14 +3607,14 @@
       </p:sp>
       <p:sp>
         <p:nvSpPr>
-          <p:cNvPr id="6" name="TextBox 5"/>
+          <p:cNvPr id="7" name="TextBox 6"/>
           <p:cNvSpPr txBox="1"/>
           <p:nvPr/>
         </p:nvSpPr>
         <p:spPr>
           <a:xfrm>
-            <a:off x="868680" y="1645920"/>
-            <a:ext cx="4754880" cy="3383280"/>
+            <a:off x="6492240" y="1645920"/>
+            <a:ext cx="4754880" cy="3291840"/>
           </a:xfrm>
           <a:prstGeom prst="rect">
             <a:avLst/>
@@ -3621,27 +3631,28 @@
               <a:spcAft>
                 <a:spcPts val="1200"/>
               </a:spcAft>
-              <a:defRPr sz="1200" b="1">
-                <a:solidFill>
-                  <a:srgbClr val="0A2240"/>
-                </a:solidFill>
-                <a:latin typeface="Arial"/>
-              </a:defRPr>
-            </a:pPr>
-            <a:r>
-              <a:t>THE INFORMATION GAP</a:t>
-            </a:r>
-          </a:p>
-          <a:p>
-            <a:pPr>
-              <a:defRPr b="1" sz="1300">
-                <a:solidFill>
-                  <a:srgbClr val="212529"/>
-                </a:solidFill>
-              </a:defRPr>
-            </a:pPr>
-            <a:r>
-              <a:t>• The Tax Engine Requirement</a:t>
+              <a:defRPr sz="1300" b="1">
+                <a:solidFill>
+                  <a:srgbClr val="007382"/>
+                </a:solidFill>
+                <a:latin typeface="Calibri"/>
+              </a:defRPr>
+            </a:pPr>
+            <a:r>
+              <a:t>THE ENRICHMENT SOLUTION</a:t>
+            </a:r>
+          </a:p>
+          <a:p>
+            <a:pPr>
+              <a:defRPr b="1" sz="1400">
+                <a:solidFill>
+                  <a:srgbClr val="282D34"/>
+                </a:solidFill>
+                <a:latin typeface="Calibri"/>
+              </a:defRPr>
+            </a:pPr>
+            <a:r>
+              <a:t>Web Specification Enrichment</a:t>
             </a:r>
           </a:p>
           <a:p>
@@ -3649,62 +3660,65 @@
               <a:spcAft>
                 <a:spcPts val="1200"/>
               </a:spcAft>
-              <a:defRPr sz="1200">
-                <a:solidFill>
-                  <a:srgbClr val="5A6473"/>
-                </a:solidFill>
-              </a:defRPr>
-            </a:pPr>
-            <a:r>
-              <a:t>Vertex's tax engine (O-Series) needs extremely granular product details (ingredients, sweeteners, alcohol content, packaging format) to compute correct tax.</a:t>
-            </a:r>
-          </a:p>
-          <a:p>
-            <a:pPr>
-              <a:defRPr b="1" sz="1300">
-                <a:solidFill>
-                  <a:srgbClr val="212529"/>
-                </a:solidFill>
-              </a:defRPr>
-            </a:pPr>
-            <a:r>
-              <a:t>• The Retailer Data Gap</a:t>
-            </a:r>
-          </a:p>
-          <a:p>
-            <a:pPr>
-              <a:defRPr sz="1200">
-                <a:solidFill>
-                  <a:srgbClr val="5A6473"/>
-                </a:solidFill>
-              </a:defRPr>
-            </a:pPr>
-            <a:r>
-              <a:t>Big-box retailers rarely have this level of detail. They only provide product titles (e.g., 'Lipton CB Unswet Blk Tea 14oz') which are brief and highly abbreviated.</a:t>
-            </a:r>
-          </a:p>
-        </p:txBody>
-      </p:sp>
-      <p:sp>
-        <p:nvSpPr>
-          <p:cNvPr id="7" name="Rounded Rectangle 6"/>
+              <a:defRPr sz="1300">
+                <a:solidFill>
+                  <a:srgbClr val="646973"/>
+                </a:solidFill>
+                <a:latin typeface="Calibri"/>
+              </a:defRPr>
+            </a:pPr>
+            <a:r>
+              <a:t>We build an Enrichment Pipeline that crawls the web for deep product specifications based on the retailer's short product title.</a:t>
+            </a:r>
+          </a:p>
+          <a:p>
+            <a:pPr>
+              <a:defRPr b="1" sz="1400">
+                <a:solidFill>
+                  <a:srgbClr val="282D34"/>
+                </a:solidFill>
+                <a:latin typeface="Calibri"/>
+              </a:defRPr>
+            </a:pPr>
+            <a:r>
+              <a:t>The Noise &amp; Tax Audit Risk Linchpin</a:t>
+            </a:r>
+          </a:p>
+          <a:p>
+            <a:pPr>
+              <a:defRPr sz="1300">
+                <a:solidFill>
+                  <a:srgbClr val="646973"/>
+                </a:solidFill>
+                <a:latin typeface="Calibri"/>
+              </a:defRPr>
+            </a:pPr>
+            <a:r>
+              <a:t>Search engines return noisy results. Mixing up different formats (Tea Bags vs Liquid Bottle) or formula (Sugar-Free vs Original) causes wrong tax classifications and massive client audit risks.</a:t>
+            </a:r>
+          </a:p>
+        </p:txBody>
+      </p:sp>
+      <p:sp>
+        <p:nvSpPr>
+          <p:cNvPr id="8" name="Rounded Rectangle 7"/>
           <p:cNvSpPr/>
           <p:nvPr/>
         </p:nvSpPr>
         <p:spPr>
           <a:xfrm>
-            <a:off x="6385255" y="1463040"/>
-            <a:ext cx="5120640" cy="3749039"/>
+            <a:off x="731520" y="5303520"/>
+            <a:ext cx="10698480" cy="731520"/>
           </a:xfrm>
           <a:prstGeom prst="roundRect">
             <a:avLst/>
           </a:prstGeom>
           <a:solidFill>
-            <a:srgbClr val="F5F7FA"/>
+            <a:srgbClr val="FEF5F5"/>
           </a:solidFill>
-          <a:ln w="12700">
+          <a:ln w="19050">
             <a:solidFill>
-              <a:srgbClr val="DCE1E6"/>
+              <a:srgbClr val="BE3232"/>
             </a:solidFill>
           </a:ln>
         </p:spPr>
@@ -3732,14 +3746,14 @@
       </p:sp>
       <p:sp>
         <p:nvSpPr>
-          <p:cNvPr id="8" name="TextBox 7"/>
+          <p:cNvPr id="9" name="TextBox 8"/>
           <p:cNvSpPr txBox="1"/>
           <p:nvPr/>
         </p:nvSpPr>
         <p:spPr>
           <a:xfrm>
-            <a:off x="6568135" y="1645920"/>
-            <a:ext cx="4754880" cy="3383280"/>
+            <a:off x="914400" y="5440680"/>
+            <a:ext cx="10332720" cy="457200"/>
           </a:xfrm>
           <a:prstGeom prst="rect">
             <a:avLst/>
@@ -3752,151 +3766,16 @@
           </a:bodyPr>
           <a:lstStyle/>
           <a:p>
-            <a:pPr>
-              <a:spcAft>
-                <a:spcPts val="1200"/>
-              </a:spcAft>
-              <a:defRPr sz="1200" b="1">
-                <a:solidFill>
-                  <a:srgbClr val="00A8B5"/>
-                </a:solidFill>
-                <a:latin typeface="Arial"/>
-              </a:defRPr>
-            </a:pPr>
-            <a:r>
-              <a:t>THE ENRICHMENT SOLUTION</a:t>
-            </a:r>
-          </a:p>
-          <a:p>
-            <a:pPr>
-              <a:defRPr b="1" sz="1300">
-                <a:solidFill>
-                  <a:srgbClr val="212529"/>
-                </a:solidFill>
-              </a:defRPr>
-            </a:pPr>
-            <a:r>
-              <a:t>• Web Specification Enrichment</a:t>
-            </a:r>
-          </a:p>
-          <a:p>
-            <a:pPr>
-              <a:spcAft>
-                <a:spcPts val="1200"/>
-              </a:spcAft>
-              <a:defRPr sz="1200">
-                <a:solidFill>
-                  <a:srgbClr val="5A6473"/>
-                </a:solidFill>
-              </a:defRPr>
-            </a:pPr>
-            <a:r>
-              <a:t>We build an Enrichment Pipeline that crawls the web for deep product specifications based on the retailer's short product title.</a:t>
-            </a:r>
-          </a:p>
-          <a:p>
-            <a:pPr>
-              <a:defRPr b="1" sz="1300">
-                <a:solidFill>
-                  <a:srgbClr val="212529"/>
-                </a:solidFill>
-              </a:defRPr>
-            </a:pPr>
-            <a:r>
-              <a:t>• The Noise &amp; Tax Audit Risk Linchpin</a:t>
-            </a:r>
-          </a:p>
-          <a:p>
-            <a:pPr>
-              <a:defRPr sz="1200">
-                <a:solidFill>
-                  <a:srgbClr val="5A6473"/>
-                </a:solidFill>
-              </a:defRPr>
-            </a:pPr>
-            <a:r>
-              <a:t>Search engines return noisy results. Mixing up different formats (Tea Bags vs Liquid Bottle) or formula (Sugar-Free vs Original) causes wrong tax classifications and massive client audit risks.</a:t>
-            </a:r>
-          </a:p>
-        </p:txBody>
-      </p:sp>
-      <p:sp>
-        <p:nvSpPr>
-          <p:cNvPr id="9" name="Rounded Rectangle 8"/>
-          <p:cNvSpPr/>
-          <p:nvPr/>
-        </p:nvSpPr>
-        <p:spPr>
-          <a:xfrm>
-            <a:off x="685800" y="5394960"/>
-            <a:ext cx="10820095" cy="731520"/>
-          </a:xfrm>
-          <a:prstGeom prst="roundRect">
-            <a:avLst/>
-          </a:prstGeom>
-          <a:solidFill>
-            <a:srgbClr val="FDF3F3"/>
-          </a:solidFill>
-          <a:ln w="19050">
-            <a:solidFill>
-              <a:srgbClr val="B42828"/>
-            </a:solidFill>
-          </a:ln>
-        </p:spPr>
-        <p:style>
-          <a:lnRef idx="1">
-            <a:schemeClr val="accent1"/>
-          </a:lnRef>
-          <a:fillRef idx="3">
-            <a:schemeClr val="accent1"/>
-          </a:fillRef>
-          <a:effectRef idx="2">
-            <a:schemeClr val="accent1"/>
-          </a:effectRef>
-          <a:fontRef idx="minor">
-            <a:schemeClr val="lt1"/>
-          </a:fontRef>
-        </p:style>
-        <p:txBody>
-          <a:bodyPr rtlCol="0" anchor="ctr"/>
-          <a:lstStyle/>
-          <a:p>
-            <a:pPr algn="ctr"/>
-          </a:p>
-        </p:txBody>
-      </p:sp>
-      <p:sp>
-        <p:nvSpPr>
-          <p:cNvPr id="10" name="TextBox 9"/>
-          <p:cNvSpPr txBox="1"/>
-          <p:nvPr/>
-        </p:nvSpPr>
-        <p:spPr>
-          <a:xfrm>
-            <a:off x="868680" y="5486400"/>
-            <a:ext cx="10454335" cy="548640"/>
-          </a:xfrm>
-          <a:prstGeom prst="rect">
-            <a:avLst/>
-          </a:prstGeom>
-          <a:noFill/>
-        </p:spPr>
-        <p:txBody>
-          <a:bodyPr wrap="square">
-            <a:spAutoFit/>
-          </a:bodyPr>
-          <a:lstStyle/>
-          <a:p>
             <a:pPr algn="ctr">
               <a:defRPr sz="1400" b="1">
                 <a:solidFill>
-                  <a:srgbClr val="B42828"/>
-                </a:solidFill>
-                <a:latin typeface="Arial"/>
-              </a:defRPr>
-            </a:pPr>
-            <a:r>
-              <a:t>⚠️  CORE TAX SYSTEM RULE OF THUMB: False information is worse than no information.</a:t>
+                  <a:srgbClr val="BE3232"/>
+                </a:solidFill>
+                <a:latin typeface="Calibri"/>
+              </a:defRPr>
+            </a:pPr>
+            <a:r>
+              <a:t>CORE TAX SYSTEM RULE OF THUMB: False information is worse than no information.</a:t>
             </a:r>
           </a:p>
         </p:txBody>
@@ -3935,8 +3814,8 @@
         </p:nvSpPr>
         <p:spPr>
           <a:xfrm>
-            <a:off x="685800" y="274320"/>
-            <a:ext cx="10820095" cy="274320"/>
+            <a:off x="731520" y="365760"/>
+            <a:ext cx="10728655" cy="274320"/>
           </a:xfrm>
           <a:prstGeom prst="rect">
             <a:avLst/>
@@ -3952,9 +3831,9 @@
             <a:pPr>
               <a:defRPr sz="1000" b="1">
                 <a:solidFill>
-                  <a:srgbClr val="00A8B5"/>
-                </a:solidFill>
-                <a:latin typeface="Arial"/>
+                  <a:srgbClr val="007382"/>
+                </a:solidFill>
+                <a:latin typeface="Calibri"/>
               </a:defRPr>
             </a:pPr>
             <a:r>
@@ -3971,8 +3850,8 @@
         </p:nvSpPr>
         <p:spPr>
           <a:xfrm>
-            <a:off x="685800" y="457200"/>
-            <a:ext cx="10820095" cy="731520"/>
+            <a:off x="731520" y="594360"/>
+            <a:ext cx="10728655" cy="731520"/>
           </a:xfrm>
           <a:prstGeom prst="rect">
             <a:avLst/>
@@ -3986,11 +3865,11 @@
           <a:lstStyle/>
           <a:p>
             <a:pPr>
-              <a:defRPr sz="2800" b="1">
-                <a:solidFill>
-                  <a:srgbClr val="0A2240"/>
-                </a:solidFill>
-                <a:latin typeface="Arial"/>
+              <a:defRPr sz="3200" b="1">
+                <a:solidFill>
+                  <a:srgbClr val="0F2043"/>
+                </a:solidFill>
+                <a:latin typeface="Calibri"/>
               </a:defRPr>
             </a:pPr>
             <a:r>
@@ -4001,57 +3880,14 @@
       </p:sp>
       <p:sp>
         <p:nvSpPr>
-          <p:cNvPr id="4" name="Rectangle 3"/>
-          <p:cNvSpPr/>
-          <p:nvPr/>
-        </p:nvSpPr>
-        <p:spPr>
-          <a:xfrm>
-            <a:off x="685800" y="1188720"/>
-            <a:ext cx="1828800" cy="36576"/>
-          </a:xfrm>
-          <a:prstGeom prst="rect">
-            <a:avLst/>
-          </a:prstGeom>
-          <a:solidFill>
-            <a:srgbClr val="00A8B5"/>
-          </a:solidFill>
-          <a:ln>
-            <a:noFill/>
-          </a:ln>
-        </p:spPr>
-        <p:style>
-          <a:lnRef idx="1">
-            <a:schemeClr val="accent1"/>
-          </a:lnRef>
-          <a:fillRef idx="3">
-            <a:schemeClr val="accent1"/>
-          </a:fillRef>
-          <a:effectRef idx="2">
-            <a:schemeClr val="accent1"/>
-          </a:effectRef>
-          <a:fontRef idx="minor">
-            <a:schemeClr val="lt1"/>
-          </a:fontRef>
-        </p:style>
-        <p:txBody>
-          <a:bodyPr rtlCol="0" anchor="ctr"/>
-          <a:lstStyle/>
-          <a:p>
-            <a:pPr algn="ctr"/>
-          </a:p>
-        </p:txBody>
-      </p:sp>
-      <p:sp>
-        <p:nvSpPr>
-          <p:cNvPr id="5" name="TextBox 4"/>
+          <p:cNvPr id="4" name="TextBox 3"/>
           <p:cNvSpPr txBox="1"/>
           <p:nvPr/>
         </p:nvSpPr>
         <p:spPr>
           <a:xfrm>
-            <a:off x="685800" y="1280160"/>
-            <a:ext cx="10820095" cy="365760"/>
+            <a:off x="731520" y="1280160"/>
+            <a:ext cx="10728655" cy="365760"/>
           </a:xfrm>
           <a:prstGeom prst="rect">
             <a:avLst/>
@@ -4065,11 +3901,11 @@
           <a:lstStyle/>
           <a:p>
             <a:pPr>
-              <a:defRPr sz="1300" i="1">
-                <a:solidFill>
-                  <a:srgbClr val="5A6473"/>
-                </a:solidFill>
-                <a:latin typeface="Arial"/>
+              <a:defRPr sz="1400" i="1">
+                <a:solidFill>
+                  <a:srgbClr val="646973"/>
+                </a:solidFill>
+                <a:latin typeface="Calibri"/>
               </a:defRPr>
             </a:pPr>
             <a:r>
@@ -4080,13 +3916,13 @@
       </p:sp>
       <p:sp>
         <p:nvSpPr>
-          <p:cNvPr id="6" name="TextBox 5"/>
+          <p:cNvPr id="5" name="TextBox 4"/>
           <p:cNvSpPr txBox="1"/>
           <p:nvPr/>
         </p:nvSpPr>
         <p:spPr>
           <a:xfrm>
-            <a:off x="685800" y="1737360"/>
+            <a:off x="731520" y="1737360"/>
             <a:ext cx="5120640" cy="4572000"/>
           </a:xfrm>
           <a:prstGeom prst="rect">
@@ -4101,10 +3937,11 @@
           <a:lstStyle/>
           <a:p>
             <a:pPr>
-              <a:defRPr b="1" sz="1400">
-                <a:solidFill>
-                  <a:srgbClr val="0A2240"/>
-                </a:solidFill>
+              <a:defRPr b="1" sz="1500">
+                <a:solidFill>
+                  <a:srgbClr val="0F2043"/>
+                </a:solidFill>
+                <a:latin typeface="Calibri"/>
               </a:defRPr>
             </a:pPr>
             <a:r>
@@ -4116,10 +3953,11 @@
               <a:spcAft>
                 <a:spcPts val="1400"/>
               </a:spcAft>
-              <a:defRPr sz="1150">
-                <a:solidFill>
-                  <a:srgbClr val="5A6473"/>
-                </a:solidFill>
+              <a:defRPr sz="1300">
+                <a:solidFill>
+                  <a:srgbClr val="646973"/>
+                </a:solidFill>
+                <a:latin typeface="Calibri"/>
               </a:defRPr>
             </a:pPr>
             <a:r>
@@ -4128,10 +3966,11 @@
           </a:p>
           <a:p>
             <a:pPr>
-              <a:defRPr b="1" sz="1400">
-                <a:solidFill>
-                  <a:srgbClr val="0A2240"/>
-                </a:solidFill>
+              <a:defRPr b="1" sz="1500">
+                <a:solidFill>
+                  <a:srgbClr val="0F2043"/>
+                </a:solidFill>
+                <a:latin typeface="Calibri"/>
               </a:defRPr>
             </a:pPr>
             <a:r>
@@ -4143,10 +3982,11 @@
               <a:spcAft>
                 <a:spcPts val="1400"/>
               </a:spcAft>
-              <a:defRPr sz="1150">
-                <a:solidFill>
-                  <a:srgbClr val="5A6473"/>
-                </a:solidFill>
+              <a:defRPr sz="1300">
+                <a:solidFill>
+                  <a:srgbClr val="646973"/>
+                </a:solidFill>
+                <a:latin typeface="Calibri"/>
               </a:defRPr>
             </a:pPr>
             <a:r>
@@ -4155,10 +3995,11 @@
           </a:p>
           <a:p>
             <a:pPr>
-              <a:defRPr b="1" sz="1400">
-                <a:solidFill>
-                  <a:srgbClr val="0A2240"/>
-                </a:solidFill>
+              <a:defRPr b="1" sz="1500">
+                <a:solidFill>
+                  <a:srgbClr val="0F2043"/>
+                </a:solidFill>
+                <a:latin typeface="Calibri"/>
               </a:defRPr>
             </a:pPr>
             <a:r>
@@ -4167,10 +4008,11 @@
           </a:p>
           <a:p>
             <a:pPr>
-              <a:defRPr sz="1150">
-                <a:solidFill>
-                  <a:srgbClr val="5A6473"/>
-                </a:solidFill>
+              <a:defRPr sz="1300">
+                <a:solidFill>
+                  <a:srgbClr val="646973"/>
+                </a:solidFill>
+                <a:latin typeface="Calibri"/>
               </a:defRPr>
             </a:pPr>
             <a:r>
@@ -4181,13 +4023,13 @@
       </p:sp>
       <p:sp>
         <p:nvSpPr>
-          <p:cNvPr id="7" name="TextBox 6"/>
+          <p:cNvPr id="6" name="TextBox 5"/>
           <p:cNvSpPr txBox="1"/>
           <p:nvPr/>
         </p:nvSpPr>
         <p:spPr>
           <a:xfrm>
-            <a:off x="6385255" y="1737360"/>
+            <a:off x="6309360" y="1737360"/>
             <a:ext cx="5120640" cy="4572000"/>
           </a:xfrm>
           <a:prstGeom prst="rect">
@@ -4202,10 +4044,11 @@
           <a:lstStyle/>
           <a:p>
             <a:pPr>
-              <a:defRPr b="1" sz="1400">
-                <a:solidFill>
-                  <a:srgbClr val="0A2240"/>
-                </a:solidFill>
+              <a:defRPr b="1" sz="1500">
+                <a:solidFill>
+                  <a:srgbClr val="0F2043"/>
+                </a:solidFill>
+                <a:latin typeface="Calibri"/>
               </a:defRPr>
             </a:pPr>
             <a:r>
@@ -4217,10 +4060,11 @@
               <a:spcAft>
                 <a:spcPts val="1400"/>
               </a:spcAft>
-              <a:defRPr sz="1150">
-                <a:solidFill>
-                  <a:srgbClr val="5A6473"/>
-                </a:solidFill>
+              <a:defRPr sz="1300">
+                <a:solidFill>
+                  <a:srgbClr val="646973"/>
+                </a:solidFill>
+                <a:latin typeface="Calibri"/>
               </a:defRPr>
             </a:pPr>
             <a:r>
@@ -4229,10 +4073,11 @@
           </a:p>
           <a:p>
             <a:pPr>
-              <a:defRPr b="1" sz="1400">
-                <a:solidFill>
-                  <a:srgbClr val="0A2240"/>
-                </a:solidFill>
+              <a:defRPr b="1" sz="1500">
+                <a:solidFill>
+                  <a:srgbClr val="0F2043"/>
+                </a:solidFill>
+                <a:latin typeface="Calibri"/>
               </a:defRPr>
             </a:pPr>
             <a:r>
@@ -4244,10 +4089,11 @@
               <a:spcAft>
                 <a:spcPts val="1400"/>
               </a:spcAft>
-              <a:defRPr sz="1150">
-                <a:solidFill>
-                  <a:srgbClr val="5A6473"/>
-                </a:solidFill>
+              <a:defRPr sz="1300">
+                <a:solidFill>
+                  <a:srgbClr val="646973"/>
+                </a:solidFill>
+                <a:latin typeface="Calibri"/>
               </a:defRPr>
             </a:pPr>
             <a:r>
@@ -4256,10 +4102,11 @@
           </a:p>
           <a:p>
             <a:pPr>
-              <a:defRPr b="1" sz="1400">
-                <a:solidFill>
-                  <a:srgbClr val="0A2240"/>
-                </a:solidFill>
+              <a:defRPr b="1" sz="1500">
+                <a:solidFill>
+                  <a:srgbClr val="0F2043"/>
+                </a:solidFill>
+                <a:latin typeface="Calibri"/>
               </a:defRPr>
             </a:pPr>
             <a:r>
@@ -4268,10 +4115,11 @@
           </a:p>
           <a:p>
             <a:pPr>
-              <a:defRPr sz="1150">
-                <a:solidFill>
-                  <a:srgbClr val="5A6473"/>
-                </a:solidFill>
+              <a:defRPr sz="1300">
+                <a:solidFill>
+                  <a:srgbClr val="646973"/>
+                </a:solidFill>
+                <a:latin typeface="Calibri"/>
               </a:defRPr>
             </a:pPr>
             <a:r>
@@ -4314,8 +4162,8 @@
         </p:nvSpPr>
         <p:spPr>
           <a:xfrm>
-            <a:off x="685800" y="274320"/>
-            <a:ext cx="10820095" cy="274320"/>
+            <a:off x="731520" y="365760"/>
+            <a:ext cx="10728655" cy="274320"/>
           </a:xfrm>
           <a:prstGeom prst="rect">
             <a:avLst/>
@@ -4331,9 +4179,9 @@
             <a:pPr>
               <a:defRPr sz="1000" b="1">
                 <a:solidFill>
-                  <a:srgbClr val="00A8B5"/>
-                </a:solidFill>
-                <a:latin typeface="Arial"/>
+                  <a:srgbClr val="007382"/>
+                </a:solidFill>
+                <a:latin typeface="Calibri"/>
               </a:defRPr>
             </a:pPr>
             <a:r>
@@ -4350,8 +4198,8 @@
         </p:nvSpPr>
         <p:spPr>
           <a:xfrm>
-            <a:off x="685800" y="457200"/>
-            <a:ext cx="10820095" cy="731520"/>
+            <a:off x="731520" y="594360"/>
+            <a:ext cx="10728655" cy="731520"/>
           </a:xfrm>
           <a:prstGeom prst="rect">
             <a:avLst/>
@@ -4365,11 +4213,11 @@
           <a:lstStyle/>
           <a:p>
             <a:pPr>
-              <a:defRPr sz="2800" b="1">
-                <a:solidFill>
-                  <a:srgbClr val="0A2240"/>
-                </a:solidFill>
-                <a:latin typeface="Arial"/>
+              <a:defRPr sz="3200" b="1">
+                <a:solidFill>
+                  <a:srgbClr val="0F2043"/>
+                </a:solidFill>
+                <a:latin typeface="Calibri"/>
               </a:defRPr>
             </a:pPr>
             <a:r>
@@ -4380,23 +4228,25 @@
       </p:sp>
       <p:sp>
         <p:nvSpPr>
-          <p:cNvPr id="4" name="Rectangle 3"/>
+          <p:cNvPr id="4" name="Rounded Rectangle 3"/>
           <p:cNvSpPr/>
           <p:nvPr/>
         </p:nvSpPr>
         <p:spPr>
           <a:xfrm>
-            <a:off x="685800" y="1188720"/>
-            <a:ext cx="1828800" cy="36576"/>
-          </a:xfrm>
-          <a:prstGeom prst="rect">
+            <a:off x="731520" y="1463040"/>
+            <a:ext cx="5120640" cy="4389120"/>
+          </a:xfrm>
+          <a:prstGeom prst="roundRect">
             <a:avLst/>
           </a:prstGeom>
           <a:solidFill>
-            <a:srgbClr val="00A8B5"/>
+            <a:srgbClr val="F8F9FC"/>
           </a:solidFill>
-          <a:ln>
-            <a:noFill/>
+          <a:ln w="12700">
+            <a:solidFill>
+              <a:srgbClr val="E1E4EB"/>
+            </a:solidFill>
           </a:ln>
         </p:spPr>
         <p:style>
@@ -4423,24 +4273,142 @@
       </p:sp>
       <p:sp>
         <p:nvSpPr>
-          <p:cNvPr id="5" name="Rounded Rectangle 4"/>
+          <p:cNvPr id="5" name="TextBox 4"/>
+          <p:cNvSpPr txBox="1"/>
+          <p:nvPr/>
+        </p:nvSpPr>
+        <p:spPr>
+          <a:xfrm>
+            <a:off x="914400" y="1645920"/>
+            <a:ext cx="4754880" cy="4023360"/>
+          </a:xfrm>
+          <a:prstGeom prst="rect">
+            <a:avLst/>
+          </a:prstGeom>
+          <a:noFill/>
+        </p:spPr>
+        <p:txBody>
+          <a:bodyPr wrap="square">
+            <a:spAutoFit/>
+          </a:bodyPr>
+          <a:lstStyle/>
+          <a:p>
+            <a:pPr>
+              <a:spcAft>
+                <a:spcPts val="1000"/>
+              </a:spcAft>
+              <a:defRPr sz="1400" b="1">
+                <a:solidFill>
+                  <a:srgbClr val="0F2043"/>
+                </a:solidFill>
+                <a:latin typeface="Calibri"/>
+              </a:defRPr>
+            </a:pPr>
+            <a:r>
+              <a:t>TIER 1: SMART LOCAL HEURISTIC</a:t>
+            </a:r>
+          </a:p>
+          <a:p>
+            <a:pPr>
+              <a:spcAft>
+                <a:spcPts val="1200"/>
+              </a:spcAft>
+              <a:defRPr sz="1300" i="1">
+                <a:solidFill>
+                  <a:srgbClr val="007382"/>
+                </a:solidFill>
+                <a:latin typeface="Calibri"/>
+              </a:defRPr>
+            </a:pPr>
+            <a:r>
+              <a:t>The High-Speed, Zero-Cost Baseline Engine</a:t>
+            </a:r>
+          </a:p>
+          <a:p>
+            <a:pPr>
+              <a:defRPr b="1" sz="1350">
+                <a:solidFill>
+                  <a:srgbClr val="282D34"/>
+                </a:solidFill>
+                <a:latin typeface="Calibri"/>
+              </a:defRPr>
+            </a:pPr>
+            <a:r>
+              <a:t>Rule-Based Python Architecture</a:t>
+            </a:r>
+          </a:p>
+          <a:p>
+            <a:pPr>
+              <a:spcAft>
+                <a:spcPts val="1000"/>
+              </a:spcAft>
+              <a:defRPr sz="1250">
+                <a:solidFill>
+                  <a:srgbClr val="646973"/>
+                </a:solidFill>
+                <a:latin typeface="Calibri"/>
+              </a:defRPr>
+            </a:pPr>
+            <a:r>
+              <a:t>Tokenizes terms, filters volume indicators, matches precise brand requirements, and detects strong negative mismatches ('bags' vs liquid).</a:t>
+            </a:r>
+          </a:p>
+          <a:p>
+            <a:pPr>
+              <a:defRPr b="1" sz="1350">
+                <a:solidFill>
+                  <a:srgbClr val="282D34"/>
+                </a:solidFill>
+                <a:latin typeface="Calibri"/>
+              </a:defRPr>
+            </a:pPr>
+            <a:r>
+              <a:t>Performance Benchmarks (Offline)</a:t>
+            </a:r>
+          </a:p>
+          <a:p>
+            <a:pPr>
+              <a:defRPr sz="1250">
+                <a:solidFill>
+                  <a:srgbClr val="646973"/>
+                </a:solidFill>
+                <a:latin typeface="Calibri"/>
+              </a:defRPr>
+            </a:pPr>
+            <a:r>
+              <a:t>Latency: &lt; 1 millisecond</a:t>
+            </a:r>
+            <a:br/>
+            <a:r>
+              <a:t>API Token Cost: $0.00 (Run 100% locally)</a:t>
+            </a:r>
+            <a:br/>
+            <a:r>
+              <a:t>F1-Score: ~68.2% (Perfect as an instant fallback and local test harness)</a:t>
+            </a:r>
+          </a:p>
+        </p:txBody>
+      </p:sp>
+      <p:sp>
+        <p:nvSpPr>
+          <p:cNvPr id="6" name="Rounded Rectangle 5"/>
           <p:cNvSpPr/>
           <p:nvPr/>
         </p:nvSpPr>
         <p:spPr>
           <a:xfrm>
-            <a:off x="685800" y="1463040"/>
+            <a:off x="6309360" y="1463040"/>
             <a:ext cx="5120640" cy="4389120"/>
           </a:xfrm>
           <a:prstGeom prst="roundRect">
             <a:avLst/>
           </a:prstGeom>
           <a:solidFill>
-            <a:srgbClr val="F0F9FA"/>
+            <a:srgbClr val="F8F9FC"/>
           </a:solidFill>
-          <a:ln w="19050">
+          <a:ln w="12700">
             <a:solidFill>
-              <a:srgbClr val="00A8B5"/>
+              <a:srgbClr val="E1E4EB"/>
             </a:solidFill>
           </a:ln>
         </p:spPr>
@@ -4468,13 +4436,13 @@
       </p:sp>
       <p:sp>
         <p:nvSpPr>
-          <p:cNvPr id="6" name="TextBox 5"/>
+          <p:cNvPr id="7" name="TextBox 6"/>
           <p:cNvSpPr txBox="1"/>
           <p:nvPr/>
         </p:nvSpPr>
         <p:spPr>
           <a:xfrm>
-            <a:off x="868680" y="1645920"/>
+            <a:off x="6492240" y="1645920"/>
             <a:ext cx="4754880" cy="4023360"/>
           </a:xfrm>
           <a:prstGeom prst="rect">
@@ -4492,15 +4460,15 @@
               <a:spcAft>
                 <a:spcPts val="1000"/>
               </a:spcAft>
-              <a:defRPr sz="1300" b="1">
-                <a:solidFill>
-                  <a:srgbClr val="0A2240"/>
-                </a:solidFill>
-                <a:latin typeface="Arial"/>
-              </a:defRPr>
-            </a:pPr>
-            <a:r>
-              <a:t>TIER 1: SMART LOCAL HEURISTIC</a:t>
+              <a:defRPr sz="1400" b="1">
+                <a:solidFill>
+                  <a:srgbClr val="0F2043"/>
+                </a:solidFill>
+                <a:latin typeface="Calibri"/>
+              </a:defRPr>
+            </a:pPr>
+            <a:r>
+              <a:t>TIER 2: SOTA LLM + STRUCTURED OUTPUTS</a:t>
             </a:r>
           </a:p>
           <a:p>
@@ -4508,26 +4476,28 @@
               <a:spcAft>
                 <a:spcPts val="1200"/>
               </a:spcAft>
-              <a:defRPr sz="1200" i="1">
-                <a:solidFill>
-                  <a:srgbClr val="00A8B5"/>
-                </a:solidFill>
-              </a:defRPr>
-            </a:pPr>
-            <a:r>
-              <a:t>The High-Speed, Zero-Cost Baseline Engine</a:t>
-            </a:r>
-          </a:p>
-          <a:p>
-            <a:pPr>
-              <a:defRPr b="1" sz="1250">
-                <a:solidFill>
-                  <a:srgbClr val="212529"/>
-                </a:solidFill>
-              </a:defRPr>
-            </a:pPr>
-            <a:r>
-              <a:t>• Rule-Based Python Architecture</a:t>
+              <a:defRPr sz="1300" i="1">
+                <a:solidFill>
+                  <a:srgbClr val="007382"/>
+                </a:solidFill>
+                <a:latin typeface="Calibri"/>
+              </a:defRPr>
+            </a:pPr>
+            <a:r>
+              <a:t>The Production Model utilizing OpenAI JSON Enforcements</a:t>
+            </a:r>
+          </a:p>
+          <a:p>
+            <a:pPr>
+              <a:defRPr b="1" sz="1350">
+                <a:solidFill>
+                  <a:srgbClr val="282D34"/>
+                </a:solidFill>
+                <a:latin typeface="Calibri"/>
+              </a:defRPr>
+            </a:pPr>
+            <a:r>
+              <a:t>GPT-4o-mini with Strict Pydantic Schema</a:t>
             </a:r>
           </a:p>
           <a:p>
@@ -4535,168 +4505,11 @@
               <a:spcAft>
                 <a:spcPts val="1000"/>
               </a:spcAft>
-              <a:defRPr sz="1150">
-                <a:solidFill>
-                  <a:srgbClr val="5A6473"/>
-                </a:solidFill>
-              </a:defRPr>
-            </a:pPr>
-            <a:r>
-              <a:t>Tokenizes terms, filters volume indicators, matches precise brand requirements, and detects strong negative mismatches ('bags' vs liquid).</a:t>
-            </a:r>
-          </a:p>
-          <a:p>
-            <a:pPr>
-              <a:defRPr b="1" sz="1250">
-                <a:solidFill>
-                  <a:srgbClr val="212529"/>
-                </a:solidFill>
-              </a:defRPr>
-            </a:pPr>
-            <a:r>
-              <a:t>• Performance Benchmarks (Offline)</a:t>
-            </a:r>
-          </a:p>
-          <a:p>
-            <a:pPr>
-              <a:defRPr sz="1150">
-                <a:solidFill>
-                  <a:srgbClr val="5A6473"/>
-                </a:solidFill>
-              </a:defRPr>
-            </a:pPr>
-            <a:r>
-              <a:t>Latency: &lt; 1 millisecond</a:t>
-            </a:r>
-            <a:br/>
-            <a:r>
-              <a:t>API Token Cost: $0.00 (Run 100% locally)</a:t>
-            </a:r>
-            <a:br/>
-            <a:r>
-              <a:t>F1-Score: ~68.2% (Perfect as an instant fallback and local test harness)</a:t>
-            </a:r>
-          </a:p>
-        </p:txBody>
-      </p:sp>
-      <p:sp>
-        <p:nvSpPr>
-          <p:cNvPr id="7" name="Rounded Rectangle 6"/>
-          <p:cNvSpPr/>
-          <p:nvPr/>
-        </p:nvSpPr>
-        <p:spPr>
-          <a:xfrm>
-            <a:off x="6385255" y="1463040"/>
-            <a:ext cx="5120640" cy="4389120"/>
-          </a:xfrm>
-          <a:prstGeom prst="roundRect">
-            <a:avLst/>
-          </a:prstGeom>
-          <a:solidFill>
-            <a:srgbClr val="F5F7FA"/>
-          </a:solidFill>
-          <a:ln w="12700">
-            <a:solidFill>
-              <a:srgbClr val="DCE1E6"/>
-            </a:solidFill>
-          </a:ln>
-        </p:spPr>
-        <p:style>
-          <a:lnRef idx="1">
-            <a:schemeClr val="accent1"/>
-          </a:lnRef>
-          <a:fillRef idx="3">
-            <a:schemeClr val="accent1"/>
-          </a:fillRef>
-          <a:effectRef idx="2">
-            <a:schemeClr val="accent1"/>
-          </a:effectRef>
-          <a:fontRef idx="minor">
-            <a:schemeClr val="lt1"/>
-          </a:fontRef>
-        </p:style>
-        <p:txBody>
-          <a:bodyPr rtlCol="0" anchor="ctr"/>
-          <a:lstStyle/>
-          <a:p>
-            <a:pPr algn="ctr"/>
-          </a:p>
-        </p:txBody>
-      </p:sp>
-      <p:sp>
-        <p:nvSpPr>
-          <p:cNvPr id="8" name="TextBox 7"/>
-          <p:cNvSpPr txBox="1"/>
-          <p:nvPr/>
-        </p:nvSpPr>
-        <p:spPr>
-          <a:xfrm>
-            <a:off x="6568135" y="1645920"/>
-            <a:ext cx="4754880" cy="4023360"/>
-          </a:xfrm>
-          <a:prstGeom prst="rect">
-            <a:avLst/>
-          </a:prstGeom>
-          <a:noFill/>
-        </p:spPr>
-        <p:txBody>
-          <a:bodyPr wrap="square">
-            <a:spAutoFit/>
-          </a:bodyPr>
-          <a:lstStyle/>
-          <a:p>
-            <a:pPr>
-              <a:spcAft>
-                <a:spcPts val="1000"/>
-              </a:spcAft>
-              <a:defRPr sz="1300" b="1">
-                <a:solidFill>
-                  <a:srgbClr val="0A2240"/>
-                </a:solidFill>
-                <a:latin typeface="Arial"/>
-              </a:defRPr>
-            </a:pPr>
-            <a:r>
-              <a:t>TIER 2: SOTA LLM + STRUCTURED OUTPUTS</a:t>
-            </a:r>
-          </a:p>
-          <a:p>
-            <a:pPr>
-              <a:spcAft>
-                <a:spcPts val="1200"/>
-              </a:spcAft>
-              <a:defRPr sz="1200" i="1">
-                <a:solidFill>
-                  <a:srgbClr val="00A8B5"/>
-                </a:solidFill>
-              </a:defRPr>
-            </a:pPr>
-            <a:r>
-              <a:t>The Production Model utilizing OpenAI JSON Enforcements</a:t>
-            </a:r>
-          </a:p>
-          <a:p>
-            <a:pPr>
-              <a:defRPr b="1" sz="1250">
-                <a:solidFill>
-                  <a:srgbClr val="212529"/>
-                </a:solidFill>
-              </a:defRPr>
-            </a:pPr>
-            <a:r>
-              <a:t>• GPT-4o-mini with Strict Pydantic Schema</a:t>
-            </a:r>
-          </a:p>
-          <a:p>
-            <a:pPr>
-              <a:spcAft>
-                <a:spcPts val="1000"/>
-              </a:spcAft>
-              <a:defRPr sz="1150">
-                <a:solidFill>
-                  <a:srgbClr val="5A6473"/>
-                </a:solidFill>
+              <a:defRPr sz="1250">
+                <a:solidFill>
+                  <a:srgbClr val="646973"/>
+                </a:solidFill>
+                <a:latin typeface="Calibri"/>
               </a:defRPr>
             </a:pPr>
             <a:r>
@@ -4705,22 +4518,24 @@
           </a:p>
           <a:p>
             <a:pPr>
-              <a:defRPr b="1" sz="1250">
-                <a:solidFill>
-                  <a:srgbClr val="212529"/>
-                </a:solidFill>
-              </a:defRPr>
-            </a:pPr>
-            <a:r>
-              <a:t>• High-Context Semantic Reasoning</a:t>
-            </a:r>
-          </a:p>
-          <a:p>
-            <a:pPr>
-              <a:defRPr sz="1150">
-                <a:solidFill>
-                  <a:srgbClr val="5A6473"/>
-                </a:solidFill>
+              <a:defRPr b="1" sz="1350">
+                <a:solidFill>
+                  <a:srgbClr val="282D34"/>
+                </a:solidFill>
+                <a:latin typeface="Calibri"/>
+              </a:defRPr>
+            </a:pPr>
+            <a:r>
+              <a:t>High-Context Semantic Reasoning</a:t>
+            </a:r>
+          </a:p>
+          <a:p>
+            <a:pPr>
+              <a:defRPr sz="1250">
+                <a:solidFill>
+                  <a:srgbClr val="646973"/>
+                </a:solidFill>
+                <a:latin typeface="Calibri"/>
               </a:defRPr>
             </a:pPr>
             <a:r>
@@ -4763,8 +4578,8 @@
         </p:nvSpPr>
         <p:spPr>
           <a:xfrm>
-            <a:off x="685800" y="274320"/>
-            <a:ext cx="10820095" cy="274320"/>
+            <a:off x="731520" y="365760"/>
+            <a:ext cx="10728655" cy="274320"/>
           </a:xfrm>
           <a:prstGeom prst="rect">
             <a:avLst/>
@@ -4780,9 +4595,9 @@
             <a:pPr>
               <a:defRPr sz="1000" b="1">
                 <a:solidFill>
-                  <a:srgbClr val="00A8B5"/>
-                </a:solidFill>
-                <a:latin typeface="Arial"/>
+                  <a:srgbClr val="007382"/>
+                </a:solidFill>
+                <a:latin typeface="Calibri"/>
               </a:defRPr>
             </a:pPr>
             <a:r>
@@ -4799,8 +4614,8 @@
         </p:nvSpPr>
         <p:spPr>
           <a:xfrm>
-            <a:off x="685800" y="457200"/>
-            <a:ext cx="10820095" cy="731520"/>
+            <a:off x="731520" y="594360"/>
+            <a:ext cx="10728655" cy="731520"/>
           </a:xfrm>
           <a:prstGeom prst="rect">
             <a:avLst/>
@@ -4814,11 +4629,11 @@
           <a:lstStyle/>
           <a:p>
             <a:pPr>
-              <a:defRPr sz="2800" b="1">
-                <a:solidFill>
-                  <a:srgbClr val="0A2240"/>
-                </a:solidFill>
-                <a:latin typeface="Arial"/>
+              <a:defRPr sz="3200" b="1">
+                <a:solidFill>
+                  <a:srgbClr val="0F2043"/>
+                </a:solidFill>
+                <a:latin typeface="Calibri"/>
               </a:defRPr>
             </a:pPr>
             <a:r>
@@ -4829,23 +4644,136 @@
       </p:sp>
       <p:sp>
         <p:nvSpPr>
-          <p:cNvPr id="4" name="Rectangle 3"/>
-          <p:cNvSpPr/>
+          <p:cNvPr id="4" name="TextBox 3"/>
+          <p:cNvSpPr txBox="1"/>
           <p:nvPr/>
         </p:nvSpPr>
         <p:spPr>
           <a:xfrm>
-            <a:off x="685800" y="1188720"/>
-            <a:ext cx="1828800" cy="36576"/>
+            <a:off x="731520" y="1463040"/>
+            <a:ext cx="5486400" cy="4754880"/>
           </a:xfrm>
           <a:prstGeom prst="rect">
             <a:avLst/>
           </a:prstGeom>
+          <a:noFill/>
+        </p:spPr>
+        <p:txBody>
+          <a:bodyPr wrap="square" lIns="0">
+            <a:spAutoFit/>
+          </a:bodyPr>
+          <a:lstStyle/>
+          <a:p>
+            <a:pPr>
+              <a:defRPr b="1" sz="1600">
+                <a:solidFill>
+                  <a:srgbClr val="0F2043"/>
+                </a:solidFill>
+                <a:latin typeface="Calibri"/>
+              </a:defRPr>
+            </a:pPr>
+            <a:r>
+              <a:t>Precision (Most Critical Metric)</a:t>
+            </a:r>
+          </a:p>
+          <a:p>
+            <a:pPr>
+              <a:spcAft>
+                <a:spcPts val="1200"/>
+              </a:spcAft>
+              <a:defRPr sz="1300">
+                <a:solidFill>
+                  <a:srgbClr val="646973"/>
+                </a:solidFill>
+                <a:latin typeface="Calibri"/>
+              </a:defRPr>
+            </a:pPr>
+            <a:r>
+              <a:t>Out of the search results we mark as 'trusted', how many are actually correct? High precision is paramount to avoid feeding erroneous product specifications into downstream tax classifications.</a:t>
+            </a:r>
+          </a:p>
+          <a:p>
+            <a:pPr>
+              <a:defRPr b="1" sz="1600">
+                <a:solidFill>
+                  <a:srgbClr val="0F2043"/>
+                </a:solidFill>
+                <a:latin typeface="Calibri"/>
+              </a:defRPr>
+            </a:pPr>
+            <a:r>
+              <a:t>Recall (Secondary Volume Metric)</a:t>
+            </a:r>
+          </a:p>
+          <a:p>
+            <a:pPr>
+              <a:spcAft>
+                <a:spcPts val="1200"/>
+              </a:spcAft>
+              <a:defRPr sz="1300">
+                <a:solidFill>
+                  <a:srgbClr val="646973"/>
+                </a:solidFill>
+                <a:latin typeface="Calibri"/>
+              </a:defRPr>
+            </a:pPr>
+            <a:r>
+              <a:t>Out of all matching pages available on the web, how many did we capture? High recall guarantees we fetch enough rich text pages to make a definitive product tax determination.</a:t>
+            </a:r>
+          </a:p>
+          <a:p>
+            <a:pPr>
+              <a:defRPr b="1" sz="1600">
+                <a:solidFill>
+                  <a:srgbClr val="007382"/>
+                </a:solidFill>
+                <a:latin typeface="Calibri"/>
+              </a:defRPr>
+            </a:pPr>
+            <a:r>
+              <a:t>F0.5-Score (Our Primary Optimization Metric)</a:t>
+            </a:r>
+          </a:p>
+          <a:p>
+            <a:pPr>
+              <a:defRPr sz="1300">
+                <a:solidFill>
+                  <a:srgbClr val="646973"/>
+                </a:solidFill>
+                <a:latin typeface="Calibri"/>
+              </a:defRPr>
+            </a:pPr>
+            <a:r>
+              <a:t>F0.5 = (1.25 * Precision * Recall) / (0.25 * Precision + Recall)</a:t>
+            </a:r>
+            <a:br/>
+            <a:r>
+              <a:t>F0.5-score weights precision TWICE as heavily as recall. This mathematical choice aligns perfectly with our core tax system mandate: prioritize correctness over raw volume.</a:t>
+            </a:r>
+          </a:p>
+        </p:txBody>
+      </p:sp>
+      <p:sp>
+        <p:nvSpPr>
+          <p:cNvPr id="5" name="Rounded Rectangle 4"/>
+          <p:cNvSpPr/>
+          <p:nvPr/>
+        </p:nvSpPr>
+        <p:spPr>
+          <a:xfrm>
+            <a:off x="6492240" y="1463040"/>
+            <a:ext cx="4937760" cy="4389120"/>
+          </a:xfrm>
+          <a:prstGeom prst="roundRect">
+            <a:avLst/>
+          </a:prstGeom>
           <a:solidFill>
-            <a:srgbClr val="00A8B5"/>
+            <a:srgbClr val="F8F9FC"/>
           </a:solidFill>
-          <a:ln>
-            <a:noFill/>
+          <a:ln w="12700">
+            <a:solidFill>
+              <a:srgbClr val="E1E4EB"/>
+            </a:solidFill>
           </a:ln>
         </p:spPr>
         <p:style>
@@ -4872,14 +4800,14 @@
       </p:sp>
       <p:sp>
         <p:nvSpPr>
-          <p:cNvPr id="5" name="TextBox 4"/>
+          <p:cNvPr id="6" name="TextBox 5"/>
           <p:cNvSpPr txBox="1"/>
           <p:nvPr/>
         </p:nvSpPr>
         <p:spPr>
           <a:xfrm>
-            <a:off x="685800" y="1463040"/>
-            <a:ext cx="5486400" cy="4754880"/>
+            <a:off x="6675120" y="1645920"/>
+            <a:ext cx="4572000" cy="4023360"/>
           </a:xfrm>
           <a:prstGeom prst="rect">
             <a:avLst/>
@@ -4887,47 +4815,37 @@
           <a:noFill/>
         </p:spPr>
         <p:txBody>
-          <a:bodyPr wrap="square" lIns="0">
+          <a:bodyPr wrap="square">
             <a:spAutoFit/>
           </a:bodyPr>
           <a:lstStyle/>
-          <a:p>
-            <a:pPr>
-              <a:defRPr b="1" sz="1500">
-                <a:solidFill>
-                  <a:srgbClr val="0A2240"/>
-                </a:solidFill>
-              </a:defRPr>
-            </a:pPr>
-            <a:r>
-              <a:t>🎯 Precision (Most Critical Metric)</a:t>
-            </a:r>
-          </a:p>
           <a:p>
             <a:pPr>
               <a:spcAft>
                 <a:spcPts val="1200"/>
               </a:spcAft>
-              <a:defRPr sz="1150">
-                <a:solidFill>
-                  <a:srgbClr val="5A6473"/>
-                </a:solidFill>
-              </a:defRPr>
-            </a:pPr>
-            <a:r>
-              <a:t>Out of the search results we mark as 'trusted', how many are actually correct? High precision is paramount to avoid feeding erroneous product specifications into downstream tax classifications.</a:t>
-            </a:r>
-          </a:p>
-          <a:p>
-            <a:pPr>
-              <a:defRPr b="1" sz="1500">
-                <a:solidFill>
-                  <a:srgbClr val="0A2240"/>
-                </a:solidFill>
-              </a:defRPr>
-            </a:pPr>
-            <a:r>
-              <a:t>📈 Recall (Secondary Volume Metric)</a:t>
+              <a:defRPr sz="1300" b="1">
+                <a:solidFill>
+                  <a:srgbClr val="0F2043"/>
+                </a:solidFill>
+                <a:latin typeface="Calibri"/>
+              </a:defRPr>
+            </a:pPr>
+            <a:r>
+              <a:t>ADDITIONAL KPIS WE TRACK</a:t>
+            </a:r>
+          </a:p>
+          <a:p>
+            <a:pPr>
+              <a:defRPr b="1" sz="1400">
+                <a:solidFill>
+                  <a:srgbClr val="282D34"/>
+                </a:solidFill>
+                <a:latin typeface="Calibri"/>
+              </a:defRPr>
+            </a:pPr>
+            <a:r>
+              <a:t>Accuracy &amp; Confusion Matrix</a:t>
             </a:r>
           </a:p>
           <a:p>
@@ -4935,149 +4853,11 @@
               <a:spcAft>
                 <a:spcPts val="1200"/>
               </a:spcAft>
-              <a:defRPr sz="1150">
-                <a:solidFill>
-                  <a:srgbClr val="5A6473"/>
-                </a:solidFill>
-              </a:defRPr>
-            </a:pPr>
-            <a:r>
-              <a:t>Out of all matching pages available on the web, how many did we capture? High recall guarantees we fetch enough rich text pages to make a definitive product tax determination.</a:t>
-            </a:r>
-          </a:p>
-          <a:p>
-            <a:pPr>
-              <a:defRPr b="1" sz="1500">
-                <a:solidFill>
-                  <a:srgbClr val="00A8B5"/>
-                </a:solidFill>
-              </a:defRPr>
-            </a:pPr>
-            <a:r>
-              <a:t>⭐ F0.5-Score (Our Primary Optimization Metric)</a:t>
-            </a:r>
-          </a:p>
-          <a:p>
-            <a:pPr>
-              <a:defRPr sz="1150">
-                <a:solidFill>
-                  <a:srgbClr val="5A6473"/>
-                </a:solidFill>
-              </a:defRPr>
-            </a:pPr>
-            <a:r>
-              <a:t>F0.5 = (1.25 * Precision * Recall) / (0.25 * Precision + Recall)</a:t>
-            </a:r>
-            <a:br/>
-            <a:r>
-              <a:t>F0.5-score weights precision TWICE as heavily as recall. This mathematical choice aligns perfectly with our core tax system mandate: prioritize correctness over raw volume.</a:t>
-            </a:r>
-          </a:p>
-        </p:txBody>
-      </p:sp>
-      <p:sp>
-        <p:nvSpPr>
-          <p:cNvPr id="6" name="Rounded Rectangle 5"/>
-          <p:cNvSpPr/>
-          <p:nvPr/>
-        </p:nvSpPr>
-        <p:spPr>
-          <a:xfrm>
-            <a:off x="6537960" y="1463040"/>
-            <a:ext cx="4937760" cy="4389120"/>
-          </a:xfrm>
-          <a:prstGeom prst="roundRect">
-            <a:avLst/>
-          </a:prstGeom>
-          <a:solidFill>
-            <a:srgbClr val="F5F7FA"/>
-          </a:solidFill>
-          <a:ln w="12700">
-            <a:solidFill>
-              <a:srgbClr val="DCE1E6"/>
-            </a:solidFill>
-          </a:ln>
-        </p:spPr>
-        <p:style>
-          <a:lnRef idx="1">
-            <a:schemeClr val="accent1"/>
-          </a:lnRef>
-          <a:fillRef idx="3">
-            <a:schemeClr val="accent1"/>
-          </a:fillRef>
-          <a:effectRef idx="2">
-            <a:schemeClr val="accent1"/>
-          </a:effectRef>
-          <a:fontRef idx="minor">
-            <a:schemeClr val="lt1"/>
-          </a:fontRef>
-        </p:style>
-        <p:txBody>
-          <a:bodyPr rtlCol="0" anchor="ctr"/>
-          <a:lstStyle/>
-          <a:p>
-            <a:pPr algn="ctr"/>
-          </a:p>
-        </p:txBody>
-      </p:sp>
-      <p:sp>
-        <p:nvSpPr>
-          <p:cNvPr id="7" name="TextBox 6"/>
-          <p:cNvSpPr txBox="1"/>
-          <p:nvPr/>
-        </p:nvSpPr>
-        <p:spPr>
-          <a:xfrm>
-            <a:off x="6720840" y="1645920"/>
-            <a:ext cx="4572000" cy="4023360"/>
-          </a:xfrm>
-          <a:prstGeom prst="rect">
-            <a:avLst/>
-          </a:prstGeom>
-          <a:noFill/>
-        </p:spPr>
-        <p:txBody>
-          <a:bodyPr wrap="square">
-            <a:spAutoFit/>
-          </a:bodyPr>
-          <a:lstStyle/>
-          <a:p>
-            <a:pPr>
-              <a:spcAft>
-                <a:spcPts val="1200"/>
-              </a:spcAft>
-              <a:defRPr sz="1200" b="1">
-                <a:solidFill>
-                  <a:srgbClr val="0A2240"/>
-                </a:solidFill>
-                <a:latin typeface="Arial"/>
-              </a:defRPr>
-            </a:pPr>
-            <a:r>
-              <a:t>ADDITIONAL KPIS WE TRACK</a:t>
-            </a:r>
-          </a:p>
-          <a:p>
-            <a:pPr>
-              <a:defRPr b="1" sz="1300">
-                <a:solidFill>
-                  <a:srgbClr val="212529"/>
-                </a:solidFill>
-              </a:defRPr>
-            </a:pPr>
-            <a:r>
-              <a:t>• Accuracy &amp; Confusion Matrix</a:t>
-            </a:r>
-          </a:p>
-          <a:p>
-            <a:pPr>
-              <a:spcAft>
-                <a:spcPts val="1200"/>
-              </a:spcAft>
-              <a:defRPr sz="1150">
-                <a:solidFill>
-                  <a:srgbClr val="5A6473"/>
-                </a:solidFill>
+              <a:defRPr sz="1250">
+                <a:solidFill>
+                  <a:srgbClr val="646973"/>
+                </a:solidFill>
+                <a:latin typeface="Calibri"/>
               </a:defRPr>
             </a:pPr>
             <a:r>
@@ -5086,22 +4866,24 @@
           </a:p>
           <a:p>
             <a:pPr>
-              <a:defRPr b="1" sz="1300">
-                <a:solidFill>
-                  <a:srgbClr val="212529"/>
-                </a:solidFill>
-              </a:defRPr>
-            </a:pPr>
-            <a:r>
-              <a:t>• Operational Efficiency Metrics</a:t>
-            </a:r>
-          </a:p>
-          <a:p>
-            <a:pPr>
-              <a:defRPr sz="1150">
-                <a:solidFill>
-                  <a:srgbClr val="5A6473"/>
-                </a:solidFill>
+              <a:defRPr b="1" sz="1400">
+                <a:solidFill>
+                  <a:srgbClr val="282D34"/>
+                </a:solidFill>
+                <a:latin typeface="Calibri"/>
+              </a:defRPr>
+            </a:pPr>
+            <a:r>
+              <a:t>Operational Efficiency Metrics</a:t>
+            </a:r>
+          </a:p>
+          <a:p>
+            <a:pPr>
+              <a:defRPr sz="1250">
+                <a:solidFill>
+                  <a:srgbClr val="646973"/>
+                </a:solidFill>
+                <a:latin typeface="Calibri"/>
               </a:defRPr>
             </a:pPr>
             <a:r>
@@ -5148,8 +4930,8 @@
         </p:nvSpPr>
         <p:spPr>
           <a:xfrm>
-            <a:off x="685800" y="274320"/>
-            <a:ext cx="10820095" cy="274320"/>
+            <a:off x="731520" y="365760"/>
+            <a:ext cx="10728655" cy="274320"/>
           </a:xfrm>
           <a:prstGeom prst="rect">
             <a:avLst/>
@@ -5165,9 +4947,9 @@
             <a:pPr>
               <a:defRPr sz="1000" b="1">
                 <a:solidFill>
-                  <a:srgbClr val="00A8B5"/>
-                </a:solidFill>
-                <a:latin typeface="Arial"/>
+                  <a:srgbClr val="007382"/>
+                </a:solidFill>
+                <a:latin typeface="Calibri"/>
               </a:defRPr>
             </a:pPr>
             <a:r>
@@ -5184,8 +4966,8 @@
         </p:nvSpPr>
         <p:spPr>
           <a:xfrm>
-            <a:off x="685800" y="457200"/>
-            <a:ext cx="10820095" cy="731520"/>
+            <a:off x="731520" y="594360"/>
+            <a:ext cx="10728655" cy="731520"/>
           </a:xfrm>
           <a:prstGeom prst="rect">
             <a:avLst/>
@@ -5199,11 +4981,11 @@
           <a:lstStyle/>
           <a:p>
             <a:pPr>
-              <a:defRPr sz="2800" b="1">
-                <a:solidFill>
-                  <a:srgbClr val="0A2240"/>
-                </a:solidFill>
-                <a:latin typeface="Arial"/>
+              <a:defRPr sz="3200" b="1">
+                <a:solidFill>
+                  <a:srgbClr val="0F2043"/>
+                </a:solidFill>
+                <a:latin typeface="Calibri"/>
               </a:defRPr>
             </a:pPr>
             <a:r>
@@ -5214,23 +4996,25 @@
       </p:sp>
       <p:sp>
         <p:nvSpPr>
-          <p:cNvPr id="4" name="Rectangle 3"/>
+          <p:cNvPr id="4" name="Rounded Rectangle 3"/>
           <p:cNvSpPr/>
           <p:nvPr/>
         </p:nvSpPr>
         <p:spPr>
           <a:xfrm>
-            <a:off x="685800" y="1188720"/>
-            <a:ext cx="1828800" cy="36576"/>
-          </a:xfrm>
-          <a:prstGeom prst="rect">
+            <a:off x="731520" y="1645920"/>
+            <a:ext cx="3291840" cy="4114800"/>
+          </a:xfrm>
+          <a:prstGeom prst="roundRect">
             <a:avLst/>
           </a:prstGeom>
           <a:solidFill>
-            <a:srgbClr val="00A8B5"/>
+            <a:srgbClr val="F8F9FC"/>
           </a:solidFill>
-          <a:ln>
-            <a:noFill/>
+          <a:ln w="12700">
+            <a:solidFill>
+              <a:srgbClr val="E1E4EB"/>
+            </a:solidFill>
           </a:ln>
         </p:spPr>
         <p:style>
@@ -5257,25 +5041,92 @@
       </p:sp>
       <p:sp>
         <p:nvSpPr>
-          <p:cNvPr id="5" name="Rounded Rectangle 4"/>
+          <p:cNvPr id="5" name="TextBox 4"/>
+          <p:cNvSpPr txBox="1"/>
+          <p:nvPr/>
+        </p:nvSpPr>
+        <p:spPr>
+          <a:xfrm>
+            <a:off x="868680" y="1828800"/>
+            <a:ext cx="3017520" cy="3749039"/>
+          </a:xfrm>
+          <a:prstGeom prst="rect">
+            <a:avLst/>
+          </a:prstGeom>
+          <a:noFill/>
+        </p:spPr>
+        <p:txBody>
+          <a:bodyPr wrap="square">
+            <a:spAutoFit/>
+          </a:bodyPr>
+          <a:lstStyle/>
+          <a:p>
+            <a:pPr>
+              <a:spcAft>
+                <a:spcPts val="1200"/>
+              </a:spcAft>
+              <a:defRPr sz="1400" b="1">
+                <a:solidFill>
+                  <a:srgbClr val="0F2043"/>
+                </a:solidFill>
+                <a:latin typeface="Calibri"/>
+              </a:defRPr>
+            </a:pPr>
+            <a:r>
+              <a:t>1. ERROR DIAGNOSTICS</a:t>
+            </a:r>
+          </a:p>
+          <a:p>
+            <a:pPr>
+              <a:lnSpc>
+                <a:spcPct val="120000"/>
+              </a:lnSpc>
+              <a:defRPr sz="1250">
+                <a:solidFill>
+                  <a:srgbClr val="646973"/>
+                </a:solidFill>
+                <a:latin typeface="Calibri"/>
+              </a:defRPr>
+            </a:pPr>
+            <a:r>
+              <a:t>The evaluation harness runs against a golden validation dataset. It intercepts and logs every error:</a:t>
+            </a:r>
+            <a:br/>
+            <a:br/>
+            <a:r>
+              <a:t>• False Positives (over-trusting unrelated results)</a:t>
+            </a:r>
+            <a:br/>
+            <a:r>
+              <a:t>• False Negatives (over-filtering matching results)</a:t>
+            </a:r>
+            <a:br/>
+            <a:br/>
+            <a:r>
+              <a:t>These errors serve as prompt training feedback.</a:t>
+            </a:r>
+          </a:p>
+        </p:txBody>
+      </p:sp>
+      <p:sp>
+        <p:nvSpPr>
+          <p:cNvPr id="6" name="Rectangle 5"/>
           <p:cNvSpPr/>
           <p:nvPr/>
         </p:nvSpPr>
         <p:spPr>
           <a:xfrm>
-            <a:off x="685800" y="1645920"/>
-            <a:ext cx="3291840" cy="4114800"/>
-          </a:xfrm>
-          <a:prstGeom prst="roundRect">
+            <a:off x="4114800" y="3566160"/>
+            <a:ext cx="274320" cy="36576"/>
+          </a:xfrm>
+          <a:prstGeom prst="rect">
             <a:avLst/>
           </a:prstGeom>
           <a:solidFill>
-            <a:srgbClr val="F5F7FA"/>
+            <a:srgbClr val="007382"/>
           </a:solidFill>
-          <a:ln w="12700">
-            <a:solidFill>
-              <a:srgbClr val="DCE1E6"/>
-            </a:solidFill>
+          <a:ln>
+            <a:noFill/>
           </a:ln>
         </p:spPr>
         <p:style>
@@ -5302,91 +5153,25 @@
       </p:sp>
       <p:sp>
         <p:nvSpPr>
-          <p:cNvPr id="6" name="TextBox 5"/>
-          <p:cNvSpPr txBox="1"/>
-          <p:nvPr/>
-        </p:nvSpPr>
-        <p:spPr>
-          <a:xfrm>
-            <a:off x="822960" y="1828800"/>
-            <a:ext cx="3017520" cy="3749039"/>
-          </a:xfrm>
-          <a:prstGeom prst="rect">
-            <a:avLst/>
-          </a:prstGeom>
-          <a:noFill/>
-        </p:spPr>
-        <p:txBody>
-          <a:bodyPr wrap="square">
-            <a:spAutoFit/>
-          </a:bodyPr>
-          <a:lstStyle/>
-          <a:p>
-            <a:pPr>
-              <a:spcAft>
-                <a:spcPts val="1200"/>
-              </a:spcAft>
-              <a:defRPr sz="1300" b="1">
-                <a:solidFill>
-                  <a:srgbClr val="0A2240"/>
-                </a:solidFill>
-                <a:latin typeface="Arial"/>
-              </a:defRPr>
-            </a:pPr>
-            <a:r>
-              <a:t>1. ERROR DIAGNOSTICS</a:t>
-            </a:r>
-          </a:p>
-          <a:p>
-            <a:pPr>
-              <a:lnSpc>
-                <a:spcPct val="120000"/>
-              </a:lnSpc>
-              <a:defRPr sz="1150">
-                <a:solidFill>
-                  <a:srgbClr val="5A6473"/>
-                </a:solidFill>
-              </a:defRPr>
-            </a:pPr>
-            <a:r>
-              <a:t>The evaluation harness runs against a golden validation dataset. It intercepts and logs every error:</a:t>
-            </a:r>
-            <a:br/>
-            <a:br/>
-            <a:r>
-              <a:t>• False Positives (over-trusting unrelated results)</a:t>
-            </a:r>
-            <a:br/>
-            <a:r>
-              <a:t>• False Negatives (over-filtering matching results)</a:t>
-            </a:r>
-            <a:br/>
-            <a:br/>
-            <a:r>
-              <a:t>These errors serve as prompt training feedback.</a:t>
-            </a:r>
-          </a:p>
-        </p:txBody>
-      </p:sp>
-      <p:sp>
-        <p:nvSpPr>
-          <p:cNvPr id="7" name="Right Arrow 6"/>
+          <p:cNvPr id="7" name="Rounded Rectangle 6"/>
           <p:cNvSpPr/>
           <p:nvPr/>
         </p:nvSpPr>
         <p:spPr>
           <a:xfrm>
-            <a:off x="4069080" y="3474720"/>
-            <a:ext cx="274320" cy="274320"/>
-          </a:xfrm>
-          <a:prstGeom prst="rightArrow">
+            <a:off x="4480560" y="1645920"/>
+            <a:ext cx="3291840" cy="4114800"/>
+          </a:xfrm>
+          <a:prstGeom prst="roundRect">
             <a:avLst/>
           </a:prstGeom>
           <a:solidFill>
-            <a:srgbClr val="00A8B5"/>
+            <a:srgbClr val="F8F9FC"/>
           </a:solidFill>
-          <a:ln>
-            <a:noFill/>
+          <a:ln w="12700">
+            <a:solidFill>
+              <a:srgbClr val="007382"/>
+            </a:solidFill>
           </a:ln>
         </p:spPr>
         <p:style>
@@ -5413,25 +5198,92 @@
       </p:sp>
       <p:sp>
         <p:nvSpPr>
-          <p:cNvPr id="8" name="Rounded Rectangle 7"/>
+          <p:cNvPr id="8" name="TextBox 7"/>
+          <p:cNvSpPr txBox="1"/>
+          <p:nvPr/>
+        </p:nvSpPr>
+        <p:spPr>
+          <a:xfrm>
+            <a:off x="4617720" y="1828800"/>
+            <a:ext cx="3017520" cy="3749039"/>
+          </a:xfrm>
+          <a:prstGeom prst="rect">
+            <a:avLst/>
+          </a:prstGeom>
+          <a:noFill/>
+        </p:spPr>
+        <p:txBody>
+          <a:bodyPr wrap="square">
+            <a:spAutoFit/>
+          </a:bodyPr>
+          <a:lstStyle/>
+          <a:p>
+            <a:pPr>
+              <a:spcAft>
+                <a:spcPts val="1200"/>
+              </a:spcAft>
+              <a:defRPr sz="1400" b="1">
+                <a:solidFill>
+                  <a:srgbClr val="007382"/>
+                </a:solidFill>
+                <a:latin typeface="Calibri"/>
+              </a:defRPr>
+            </a:pPr>
+            <a:r>
+              <a:t>2. META-PROMPT OPTIMIZER</a:t>
+            </a:r>
+          </a:p>
+          <a:p>
+            <a:pPr>
+              <a:lnSpc>
+                <a:spcPct val="120000"/>
+              </a:lnSpc>
+              <a:defRPr sz="1250">
+                <a:solidFill>
+                  <a:srgbClr val="646973"/>
+                </a:solidFill>
+                <a:latin typeface="Calibri"/>
+              </a:defRPr>
+            </a:pPr>
+            <a:r>
+              <a:t>A high-capability LLM meta-optimizer takes:</a:t>
+            </a:r>
+            <a:br/>
+            <a:br/>
+            <a:r>
+              <a:t>• Current system prompt</a:t>
+            </a:r>
+            <a:br/>
+            <a:r>
+              <a:t>• Captured failing products &amp; raw search data</a:t>
+            </a:r>
+            <a:br/>
+            <a:br/>
+            <a:r>
+              <a:t>It performs root-cause diagnostics and proposes precise system instructions to prevent these specific failures.</a:t>
+            </a:r>
+          </a:p>
+        </p:txBody>
+      </p:sp>
+      <p:sp>
+        <p:nvSpPr>
+          <p:cNvPr id="9" name="Rectangle 8"/>
           <p:cNvSpPr/>
           <p:nvPr/>
         </p:nvSpPr>
         <p:spPr>
           <a:xfrm>
-            <a:off x="4449470" y="1645920"/>
-            <a:ext cx="3291840" cy="4114800"/>
-          </a:xfrm>
-          <a:prstGeom prst="roundRect">
+            <a:off x="7863840" y="3566160"/>
+            <a:ext cx="274320" cy="36576"/>
+          </a:xfrm>
+          <a:prstGeom prst="rect">
             <a:avLst/>
           </a:prstGeom>
           <a:solidFill>
-            <a:srgbClr val="F0F9FA"/>
+            <a:srgbClr val="007382"/>
           </a:solidFill>
-          <a:ln w="19050">
-            <a:solidFill>
-              <a:srgbClr val="00A8B5"/>
-            </a:solidFill>
+          <a:ln>
+            <a:noFill/>
           </a:ln>
         </p:spPr>
         <p:style>
@@ -5458,91 +5310,25 @@
       </p:sp>
       <p:sp>
         <p:nvSpPr>
-          <p:cNvPr id="9" name="TextBox 8"/>
-          <p:cNvSpPr txBox="1"/>
-          <p:nvPr/>
-        </p:nvSpPr>
-        <p:spPr>
-          <a:xfrm>
-            <a:off x="4586630" y="1828800"/>
-            <a:ext cx="3017520" cy="3749039"/>
-          </a:xfrm>
-          <a:prstGeom prst="rect">
-            <a:avLst/>
-          </a:prstGeom>
-          <a:noFill/>
-        </p:spPr>
-        <p:txBody>
-          <a:bodyPr wrap="square">
-            <a:spAutoFit/>
-          </a:bodyPr>
-          <a:lstStyle/>
-          <a:p>
-            <a:pPr>
-              <a:spcAft>
-                <a:spcPts val="1200"/>
-              </a:spcAft>
-              <a:defRPr sz="1300" b="1">
-                <a:solidFill>
-                  <a:srgbClr val="00A8B5"/>
-                </a:solidFill>
-                <a:latin typeface="Arial"/>
-              </a:defRPr>
-            </a:pPr>
-            <a:r>
-              <a:t>2. META-PROMPT OPTIMIZER</a:t>
-            </a:r>
-          </a:p>
-          <a:p>
-            <a:pPr>
-              <a:lnSpc>
-                <a:spcPct val="120000"/>
-              </a:lnSpc>
-              <a:defRPr sz="1150">
-                <a:solidFill>
-                  <a:srgbClr val="5A6473"/>
-                </a:solidFill>
-              </a:defRPr>
-            </a:pPr>
-            <a:r>
-              <a:t>A high-capability LLM meta-optimizer takes:</a:t>
-            </a:r>
-            <a:br/>
-            <a:br/>
-            <a:r>
-              <a:t>• Current system prompt</a:t>
-            </a:r>
-            <a:br/>
-            <a:r>
-              <a:t>• Captured failing products &amp; raw search data</a:t>
-            </a:r>
-            <a:br/>
-            <a:br/>
-            <a:r>
-              <a:t>It performs root-cause diagnostics and proposes precise system instructions to prevent these specific failures.</a:t>
-            </a:r>
-          </a:p>
-        </p:txBody>
-      </p:sp>
-      <p:sp>
-        <p:nvSpPr>
-          <p:cNvPr id="10" name="Right Arrow 9"/>
+          <p:cNvPr id="10" name="Rounded Rectangle 9"/>
           <p:cNvSpPr/>
           <p:nvPr/>
         </p:nvSpPr>
         <p:spPr>
           <a:xfrm>
-            <a:off x="7818120" y="3474720"/>
-            <a:ext cx="274320" cy="274320"/>
-          </a:xfrm>
-          <a:prstGeom prst="rightArrow">
+            <a:off x="8229600" y="1645920"/>
+            <a:ext cx="3291840" cy="4114800"/>
+          </a:xfrm>
+          <a:prstGeom prst="roundRect">
             <a:avLst/>
           </a:prstGeom>
           <a:solidFill>
-            <a:srgbClr val="00A8B5"/>
+            <a:srgbClr val="F8F9FC"/>
           </a:solidFill>
-          <a:ln>
-            <a:noFill/>
+          <a:ln w="12700">
+            <a:solidFill>
+              <a:srgbClr val="E1E4EB"/>
+            </a:solidFill>
           </a:ln>
         </p:spPr>
         <p:style>
@@ -5569,58 +5355,13 @@
       </p:sp>
       <p:sp>
         <p:nvSpPr>
-          <p:cNvPr id="11" name="Rounded Rectangle 10"/>
-          <p:cNvSpPr/>
-          <p:nvPr/>
-        </p:nvSpPr>
-        <p:spPr>
-          <a:xfrm>
-            <a:off x="8214055" y="1645920"/>
-            <a:ext cx="3291840" cy="4114800"/>
-          </a:xfrm>
-          <a:prstGeom prst="roundRect">
-            <a:avLst/>
-          </a:prstGeom>
-          <a:solidFill>
-            <a:srgbClr val="F5F7FA"/>
-          </a:solidFill>
-          <a:ln w="12700">
-            <a:solidFill>
-              <a:srgbClr val="DCE1E6"/>
-            </a:solidFill>
-          </a:ln>
-        </p:spPr>
-        <p:style>
-          <a:lnRef idx="1">
-            <a:schemeClr val="accent1"/>
-          </a:lnRef>
-          <a:fillRef idx="3">
-            <a:schemeClr val="accent1"/>
-          </a:fillRef>
-          <a:effectRef idx="2">
-            <a:schemeClr val="accent1"/>
-          </a:effectRef>
-          <a:fontRef idx="minor">
-            <a:schemeClr val="lt1"/>
-          </a:fontRef>
-        </p:style>
-        <p:txBody>
-          <a:bodyPr rtlCol="0" anchor="ctr"/>
-          <a:lstStyle/>
-          <a:p>
-            <a:pPr algn="ctr"/>
-          </a:p>
-        </p:txBody>
-      </p:sp>
-      <p:sp>
-        <p:nvSpPr>
-          <p:cNvPr id="12" name="TextBox 11"/>
+          <p:cNvPr id="11" name="TextBox 10"/>
           <p:cNvSpPr txBox="1"/>
           <p:nvPr/>
         </p:nvSpPr>
         <p:spPr>
           <a:xfrm>
-            <a:off x="8351215" y="1828800"/>
+            <a:off x="8366760" y="1828800"/>
             <a:ext cx="3017520" cy="3749039"/>
           </a:xfrm>
           <a:prstGeom prst="rect">
@@ -5638,11 +5379,11 @@
               <a:spcAft>
                 <a:spcPts val="1200"/>
               </a:spcAft>
-              <a:defRPr sz="1300" b="1">
-                <a:solidFill>
-                  <a:srgbClr val="0A2240"/>
-                </a:solidFill>
-                <a:latin typeface="Arial"/>
+              <a:defRPr sz="1400" b="1">
+                <a:solidFill>
+                  <a:srgbClr val="0F2043"/>
+                </a:solidFill>
+                <a:latin typeface="Calibri"/>
               </a:defRPr>
             </a:pPr>
             <a:r>
@@ -5654,10 +5395,11 @@
               <a:lnSpc>
                 <a:spcPct val="120000"/>
               </a:lnSpc>
-              <a:defRPr sz="1150">
-                <a:solidFill>
-                  <a:srgbClr val="5A6473"/>
-                </a:solidFill>
+              <a:defRPr sz="1250">
+                <a:solidFill>
+                  <a:srgbClr val="646973"/>
+                </a:solidFill>
+                <a:latin typeface="Calibri"/>
               </a:defRPr>
             </a:pPr>
             <a:r>
@@ -5714,8 +5456,8 @@
         </p:nvSpPr>
         <p:spPr>
           <a:xfrm>
-            <a:off x="685800" y="274320"/>
-            <a:ext cx="10820095" cy="274320"/>
+            <a:off x="731520" y="365760"/>
+            <a:ext cx="10728655" cy="274320"/>
           </a:xfrm>
           <a:prstGeom prst="rect">
             <a:avLst/>
@@ -5731,9 +5473,9 @@
             <a:pPr>
               <a:defRPr sz="1000" b="1">
                 <a:solidFill>
-                  <a:srgbClr val="00A8B5"/>
-                </a:solidFill>
-                <a:latin typeface="Arial"/>
+                  <a:srgbClr val="007382"/>
+                </a:solidFill>
+                <a:latin typeface="Calibri"/>
               </a:defRPr>
             </a:pPr>
             <a:r>
@@ -5750,8 +5492,8 @@
         </p:nvSpPr>
         <p:spPr>
           <a:xfrm>
-            <a:off x="685800" y="457200"/>
-            <a:ext cx="10820095" cy="731520"/>
+            <a:off x="731520" y="594360"/>
+            <a:ext cx="10728655" cy="731520"/>
           </a:xfrm>
           <a:prstGeom prst="rect">
             <a:avLst/>
@@ -5765,11 +5507,11 @@
           <a:lstStyle/>
           <a:p>
             <a:pPr>
-              <a:defRPr sz="2800" b="1">
-                <a:solidFill>
-                  <a:srgbClr val="0A2240"/>
-                </a:solidFill>
-                <a:latin typeface="Arial"/>
+              <a:defRPr sz="3200" b="1">
+                <a:solidFill>
+                  <a:srgbClr val="0F2043"/>
+                </a:solidFill>
+                <a:latin typeface="Calibri"/>
               </a:defRPr>
             </a:pPr>
             <a:r>
@@ -5780,23 +5522,25 @@
       </p:sp>
       <p:sp>
         <p:nvSpPr>
-          <p:cNvPr id="4" name="Rectangle 3"/>
+          <p:cNvPr id="4" name="Rounded Rectangle 3"/>
           <p:cNvSpPr/>
           <p:nvPr/>
         </p:nvSpPr>
         <p:spPr>
           <a:xfrm>
-            <a:off x="685800" y="1188720"/>
-            <a:ext cx="1828800" cy="36576"/>
-          </a:xfrm>
-          <a:prstGeom prst="rect">
+            <a:off x="731520" y="1463040"/>
+            <a:ext cx="5120640" cy="4754880"/>
+          </a:xfrm>
+          <a:prstGeom prst="roundRect">
             <a:avLst/>
           </a:prstGeom>
           <a:solidFill>
-            <a:srgbClr val="00A8B5"/>
+            <a:srgbClr val="F8F9FC"/>
           </a:solidFill>
-          <a:ln>
-            <a:noFill/>
+          <a:ln w="12700">
+            <a:solidFill>
+              <a:srgbClr val="007382"/>
+            </a:solidFill>
           </a:ln>
         </p:spPr>
         <p:style>
@@ -5823,24 +5567,151 @@
       </p:sp>
       <p:sp>
         <p:nvSpPr>
-          <p:cNvPr id="5" name="Rounded Rectangle 4"/>
+          <p:cNvPr id="5" name="TextBox 4"/>
+          <p:cNvSpPr txBox="1"/>
+          <p:nvPr/>
+        </p:nvSpPr>
+        <p:spPr>
+          <a:xfrm>
+            <a:off x="914400" y="1645920"/>
+            <a:ext cx="4754880" cy="4389120"/>
+          </a:xfrm>
+          <a:prstGeom prst="rect">
+            <a:avLst/>
+          </a:prstGeom>
+          <a:noFill/>
+        </p:spPr>
+        <p:txBody>
+          <a:bodyPr wrap="square">
+            <a:spAutoFit/>
+          </a:bodyPr>
+          <a:lstStyle/>
+          <a:p>
+            <a:pPr>
+              <a:spcAft>
+                <a:spcPts val="1000"/>
+              </a:spcAft>
+              <a:defRPr sz="1400" b="1">
+                <a:solidFill>
+                  <a:srgbClr val="0F2043"/>
+                </a:solidFill>
+                <a:latin typeface="Calibri"/>
+              </a:defRPr>
+            </a:pPr>
+            <a:r>
+              <a:t>REAL-WORLD BENCHMARKS (50 PRODUCTS)</a:t>
+            </a:r>
+          </a:p>
+          <a:p>
+            <a:pPr>
+              <a:defRPr b="1" sz="1400">
+                <a:solidFill>
+                  <a:srgbClr val="0F2043"/>
+                </a:solidFill>
+                <a:latin typeface="Calibri"/>
+              </a:defRPr>
+            </a:pPr>
+            <a:r>
+              <a:t>Micro Precision: 91.36%</a:t>
+            </a:r>
+          </a:p>
+          <a:p>
+            <a:pPr>
+              <a:spcAft>
+                <a:spcPts val="800"/>
+              </a:spcAft>
+              <a:defRPr sz="1200">
+                <a:solidFill>
+                  <a:srgbClr val="646973"/>
+                </a:solidFill>
+                <a:latin typeface="Calibri"/>
+              </a:defRPr>
+            </a:pPr>
+            <a:r>
+              <a:t>Ensures robust tax audit compliance by successfully filtering false product matches out of downstream datasets.</a:t>
+            </a:r>
+          </a:p>
+          <a:p>
+            <a:pPr>
+              <a:defRPr b="1" sz="1400">
+                <a:solidFill>
+                  <a:srgbClr val="007382"/>
+                </a:solidFill>
+                <a:latin typeface="Calibri"/>
+              </a:defRPr>
+            </a:pPr>
+            <a:r>
+              <a:t>F0.5 Score (Primary Metric): 83.24%</a:t>
+            </a:r>
+          </a:p>
+          <a:p>
+            <a:pPr>
+              <a:spcAft>
+                <a:spcPts val="800"/>
+              </a:spcAft>
+              <a:defRPr sz="1200">
+                <a:solidFill>
+                  <a:srgbClr val="646973"/>
+                </a:solidFill>
+                <a:latin typeface="Calibri"/>
+              </a:defRPr>
+            </a:pPr>
+            <a:r>
+              <a:t>F1 metric score is 73.45% (with 61.41% Recall). High F0.5 weighting confirms our pipeline is mathematically tuned for accuracy over volume.</a:t>
+            </a:r>
+          </a:p>
+          <a:p>
+            <a:pPr>
+              <a:defRPr b="1" sz="1400">
+                <a:solidFill>
+                  <a:srgbClr val="282D34"/>
+                </a:solidFill>
+                <a:latin typeface="Calibri"/>
+              </a:defRPr>
+            </a:pPr>
+            <a:r>
+              <a:t>Speed &amp; Cost-Efficiency</a:t>
+            </a:r>
+          </a:p>
+          <a:p>
+            <a:pPr>
+              <a:defRPr sz="1200">
+                <a:solidFill>
+                  <a:srgbClr val="646973"/>
+                </a:solidFill>
+                <a:latin typeface="Calibri"/>
+              </a:defRPr>
+            </a:pPr>
+            <a:r>
+              <a:t>• Execution Time: 29.54s (~0.59s per product via ThreadPools)</a:t>
+            </a:r>
+            <a:br/>
+            <a:r>
+              <a:t>• Estimated Run Cost: $0.0268 total (~$5.36 per 10k products)</a:t>
+            </a:r>
+          </a:p>
+        </p:txBody>
+      </p:sp>
+      <p:sp>
+        <p:nvSpPr>
+          <p:cNvPr id="6" name="Rounded Rectangle 5"/>
           <p:cNvSpPr/>
           <p:nvPr/>
         </p:nvSpPr>
         <p:spPr>
           <a:xfrm>
-            <a:off x="685800" y="1463040"/>
+            <a:off x="6309360" y="1463040"/>
             <a:ext cx="5120640" cy="4754880"/>
           </a:xfrm>
           <a:prstGeom prst="roundRect">
             <a:avLst/>
           </a:prstGeom>
           <a:solidFill>
-            <a:srgbClr val="F0F9FA"/>
+            <a:srgbClr val="F8F9FC"/>
           </a:solidFill>
-          <a:ln w="19050">
+          <a:ln w="12700">
             <a:solidFill>
-              <a:srgbClr val="00A8B5"/>
+              <a:srgbClr val="E1E4EB"/>
             </a:solidFill>
           </a:ln>
         </p:spPr>
@@ -5868,13 +5739,13 @@
       </p:sp>
       <p:sp>
         <p:nvSpPr>
-          <p:cNvPr id="6" name="TextBox 5"/>
+          <p:cNvPr id="7" name="TextBox 6"/>
           <p:cNvSpPr txBox="1"/>
           <p:nvPr/>
         </p:nvSpPr>
         <p:spPr>
           <a:xfrm>
-            <a:off x="868680" y="1645920"/>
+            <a:off x="6492240" y="1645920"/>
             <a:ext cx="4754880" cy="4389120"/>
           </a:xfrm>
           <a:prstGeom prst="rect">
@@ -5892,27 +5763,15 @@
               <a:spcAft>
                 <a:spcPts val="1000"/>
               </a:spcAft>
-              <a:defRPr sz="1300" b="1">
-                <a:solidFill>
-                  <a:srgbClr val="0A2240"/>
-                </a:solidFill>
-                <a:latin typeface="Arial"/>
-              </a:defRPr>
-            </a:pPr>
-            <a:r>
-              <a:t>REAL-WORLD BENCHMARKS (50 PRODUCTS)</a:t>
-            </a:r>
-          </a:p>
-          <a:p>
-            <a:pPr>
-              <a:defRPr b="1" sz="1350">
-                <a:solidFill>
-                  <a:srgbClr val="0A2240"/>
-                </a:solidFill>
-              </a:defRPr>
-            </a:pPr>
-            <a:r>
-              <a:t>🎯 Micro Precision: 91.36%</a:t>
+              <a:defRPr sz="1400" b="1">
+                <a:solidFill>
+                  <a:srgbClr val="0F2043"/>
+                </a:solidFill>
+                <a:latin typeface="Calibri"/>
+              </a:defRPr>
+            </a:pPr>
+            <a:r>
+              <a:t>PREMIUM TUI CONTROL DASHBOARD</a:t>
             </a:r>
           </a:p>
           <a:p>
@@ -5920,93 +5779,169 @@
               <a:spcAft>
                 <a:spcPts val="800"/>
               </a:spcAft>
-              <a:defRPr sz="1100">
-                <a:solidFill>
-                  <a:srgbClr val="5A6473"/>
-                </a:solidFill>
-              </a:defRPr>
-            </a:pPr>
-            <a:r>
-              <a:t>Ensures robust tax audit compliance by successfully filtering false product matches out of downstream datasets.</a:t>
-            </a:r>
-          </a:p>
-          <a:p>
-            <a:pPr>
-              <a:defRPr b="1" sz="1350">
-                <a:solidFill>
-                  <a:srgbClr val="00A8B5"/>
-                </a:solidFill>
-              </a:defRPr>
-            </a:pPr>
-            <a:r>
-              <a:t>⭐ F0.5 Score (Primary Metric): 83.24%</a:t>
-            </a:r>
-          </a:p>
-          <a:p>
-            <a:pPr>
-              <a:spcAft>
-                <a:spcPts val="800"/>
-              </a:spcAft>
-              <a:defRPr sz="1100">
-                <a:solidFill>
-                  <a:srgbClr val="5A6473"/>
-                </a:solidFill>
-              </a:defRPr>
-            </a:pPr>
-            <a:r>
-              <a:t>F1 metric score is 73.45% (with 61.41% Recall). High F0.5 weighting confirms our pipeline is mathematically tuned for accuracy over volume.</a:t>
-            </a:r>
-          </a:p>
-          <a:p>
-            <a:pPr>
-              <a:defRPr b="1" sz="1350">
-                <a:solidFill>
-                  <a:srgbClr val="212529"/>
-                </a:solidFill>
-              </a:defRPr>
-            </a:pPr>
-            <a:r>
-              <a:t>⚡ Speed &amp; Cost-Efficiency</a:t>
-            </a:r>
-          </a:p>
-          <a:p>
-            <a:pPr>
-              <a:defRPr sz="1100">
-                <a:solidFill>
-                  <a:srgbClr val="5A6473"/>
-                </a:solidFill>
-              </a:defRPr>
-            </a:pPr>
-            <a:r>
-              <a:t>• Execution Time: 29.54s (~0.59s per product via ThreadPools)</a:t>
+              <a:defRPr sz="1200">
+                <a:solidFill>
+                  <a:srgbClr val="646973"/>
+                </a:solidFill>
+                <a:latin typeface="Calibri"/>
+              </a:defRPr>
+            </a:pPr>
+            <a:r>
+              <a:t>A professional, 10-option interactive bash console (menu.sh) handles complex AI operations in a user-friendly CLI:</a:t>
+            </a:r>
+          </a:p>
+          <a:p>
+            <a:pPr>
+              <a:lnSpc>
+                <a:spcPct val="115000"/>
+              </a:lnSpc>
+              <a:defRPr sz="1200">
+                <a:solidFill>
+                  <a:srgbClr val="282D34"/>
+                </a:solidFill>
+                <a:latin typeface="Calibri"/>
+              </a:defRPr>
+            </a:pPr>
+            <a:r>
+              <a:t>• [1-3] Operational Pipelines: Run mock baselines or parallel OpenAI threads on custom product datasets.</a:t>
             </a:r>
             <a:br/>
             <a:r>
-              <a:t>• Estimated Run Cost: $0.0268 total (~$5.36 per 10k products)</a:t>
-            </a:r>
-          </a:p>
-        </p:txBody>
-      </p:sp>
-      <p:sp>
-        <p:nvSpPr>
-          <p:cNvPr id="7" name="Rounded Rectangle 6"/>
+              <a:t>• [4] Auto-Prompt Optimizer: Self-tuning loop to dynamically fix prompt instructions based on failure sets.</a:t>
+            </a:r>
+            <a:br/>
+            <a:r>
+              <a:t>• [5] Visual side-by-side Prompt Diff: Instantly review optimized vs baseline guidelines via diff_prompts.py.</a:t>
+            </a:r>
+            <a:br/>
+            <a:r>
+              <a:t>• [6-7] Presentations &amp; Reports: Auto-generate visual browser dashboards (training_runs_report.md) &amp; slides.</a:t>
+            </a:r>
+            <a:br/>
+            <a:r>
+              <a:t>• [9] Saved Pipeline Summaries: Quickly fetch local summaries (evaluation_report_summary.txt).</a:t>
+            </a:r>
+          </a:p>
+        </p:txBody>
+      </p:sp>
+    </p:spTree>
+  </p:cSld>
+  <p:clrMapOvr>
+    <a:masterClrMapping/>
+  </p:clrMapOvr>
+</p:sld>
+</file>
+
+<file path=ppt/slides/slide8.xml><?xml version="1.0" encoding="utf-8"?>
+<p:sld xmlns:a="http://schemas.openxmlformats.org/drawingml/2006/main" xmlns:p="http://schemas.openxmlformats.org/presentationml/2006/main" xmlns:r="http://schemas.openxmlformats.org/officeDocument/2006/relationships">
+  <p:cSld>
+    <p:bg>
+      <p:bgPr>
+        <a:solidFill>
+          <a:srgbClr val="FFFFFF"/>
+        </a:solidFill>
+        <a:effectLst/>
+      </p:bgPr>
+    </p:bg>
+    <p:spTree>
+      <p:nvGrpSpPr>
+        <p:cNvPr id="1" name=""/>
+        <p:cNvGrpSpPr/>
+        <p:nvPr/>
+      </p:nvGrpSpPr>
+      <p:grpSpPr/>
+      <p:sp>
+        <p:nvSpPr>
+          <p:cNvPr id="2" name="TextBox 1"/>
+          <p:cNvSpPr txBox="1"/>
+          <p:nvPr/>
+        </p:nvSpPr>
+        <p:spPr>
+          <a:xfrm>
+            <a:off x="731520" y="365760"/>
+            <a:ext cx="10728655" cy="274320"/>
+          </a:xfrm>
+          <a:prstGeom prst="rect">
+            <a:avLst/>
+          </a:prstGeom>
+          <a:noFill/>
+        </p:spPr>
+        <p:txBody>
+          <a:bodyPr wrap="square" tIns="0" bIns="0" lIns="0">
+            <a:spAutoFit/>
+          </a:bodyPr>
+          <a:lstStyle/>
+          <a:p>
+            <a:pPr>
+              <a:defRPr sz="1000" b="1">
+                <a:solidFill>
+                  <a:srgbClr val="007382"/>
+                </a:solidFill>
+                <a:latin typeface="Calibri"/>
+              </a:defRPr>
+            </a:pPr>
+            <a:r>
+              <a:t>VERTEX SMART CATEGORIZATION ENGINE</a:t>
+            </a:r>
+          </a:p>
+        </p:txBody>
+      </p:sp>
+      <p:sp>
+        <p:nvSpPr>
+          <p:cNvPr id="3" name="TextBox 2"/>
+          <p:cNvSpPr txBox="1"/>
+          <p:nvPr/>
+        </p:nvSpPr>
+        <p:spPr>
+          <a:xfrm>
+            <a:off x="731520" y="594360"/>
+            <a:ext cx="10728655" cy="731520"/>
+          </a:xfrm>
+          <a:prstGeom prst="rect">
+            <a:avLst/>
+          </a:prstGeom>
+          <a:noFill/>
+        </p:spPr>
+        <p:txBody>
+          <a:bodyPr wrap="square" tIns="0" bIns="0" lIns="0">
+            <a:spAutoFit/>
+          </a:bodyPr>
+          <a:lstStyle/>
+          <a:p>
+            <a:pPr>
+              <a:defRPr sz="3200" b="1">
+                <a:solidFill>
+                  <a:srgbClr val="0F2043"/>
+                </a:solidFill>
+                <a:latin typeface="Calibri"/>
+              </a:defRPr>
+            </a:pPr>
+            <a:r>
+              <a:t>Operational Impact &amp; Roadmap</a:t>
+            </a:r>
+          </a:p>
+        </p:txBody>
+      </p:sp>
+      <p:sp>
+        <p:nvSpPr>
+          <p:cNvPr id="4" name="Rounded Rectangle 3"/>
           <p:cNvSpPr/>
           <p:nvPr/>
         </p:nvSpPr>
         <p:spPr>
           <a:xfrm>
-            <a:off x="6385255" y="1463040"/>
-            <a:ext cx="5120640" cy="4754880"/>
+            <a:off x="731520" y="1463040"/>
+            <a:ext cx="5120640" cy="4389120"/>
           </a:xfrm>
           <a:prstGeom prst="roundRect">
             <a:avLst/>
           </a:prstGeom>
           <a:solidFill>
-            <a:srgbClr val="F5F7FA"/>
+            <a:srgbClr val="F8F9FC"/>
           </a:solidFill>
           <a:ln w="12700">
             <a:solidFill>
-              <a:srgbClr val="DCE1E6"/>
+              <a:srgbClr val="007382"/>
             </a:solidFill>
           </a:ln>
         </p:spPr>
@@ -6034,14 +5969,14 @@
       </p:sp>
       <p:sp>
         <p:nvSpPr>
-          <p:cNvPr id="8" name="TextBox 7"/>
+          <p:cNvPr id="5" name="TextBox 4"/>
           <p:cNvSpPr txBox="1"/>
           <p:nvPr/>
         </p:nvSpPr>
         <p:spPr>
           <a:xfrm>
-            <a:off x="6568135" y="1645920"/>
-            <a:ext cx="4754880" cy="4389120"/>
+            <a:off x="914400" y="1645920"/>
+            <a:ext cx="4754880" cy="4023360"/>
           </a:xfrm>
           <a:prstGeom prst="rect">
             <a:avLst/>
@@ -6056,184 +5991,126 @@
           <a:p>
             <a:pPr>
               <a:spcAft>
-                <a:spcPts val="1000"/>
+                <a:spcPts val="1200"/>
               </a:spcAft>
               <a:defRPr sz="1300" b="1">
                 <a:solidFill>
-                  <a:srgbClr val="0A2240"/>
-                </a:solidFill>
-                <a:latin typeface="Arial"/>
-              </a:defRPr>
-            </a:pPr>
-            <a:r>
-              <a:t>PREMIUM TUI CONTROL DASHBOARD</a:t>
+                  <a:srgbClr val="007382"/>
+                </a:solidFill>
+                <a:latin typeface="Calibri"/>
+              </a:defRPr>
+            </a:pPr>
+            <a:r>
+              <a:t>EXPECTED OPERATIONAL PERFORMANCE</a:t>
+            </a:r>
+          </a:p>
+          <a:p>
+            <a:pPr>
+              <a:defRPr b="1" sz="1350">
+                <a:solidFill>
+                  <a:srgbClr val="0F2043"/>
+                </a:solidFill>
+                <a:latin typeface="Calibri"/>
+              </a:defRPr>
+            </a:pPr>
+            <a:r>
+              <a:t>Accuracy &amp; Confidence</a:t>
             </a:r>
           </a:p>
           <a:p>
             <a:pPr>
               <a:spcAft>
-                <a:spcPts val="800"/>
+                <a:spcPts val="1200"/>
               </a:spcAft>
-              <a:defRPr sz="1100">
-                <a:solidFill>
-                  <a:srgbClr val="5A6473"/>
-                </a:solidFill>
-              </a:defRPr>
-            </a:pPr>
-            <a:r>
-              <a:t>A professional, 10-option interactive bash console (menu.sh) handles complex AI operations in a user-friendly CLI:</a:t>
-            </a:r>
-          </a:p>
-          <a:p>
-            <a:pPr>
-              <a:lnSpc>
-                <a:spcPct val="115000"/>
-              </a:lnSpc>
-              <a:defRPr sz="1100">
-                <a:solidFill>
-                  <a:srgbClr val="212529"/>
-                </a:solidFill>
-              </a:defRPr>
-            </a:pPr>
-            <a:r>
-              <a:t>• [1-3] Operational Pipelines: Run mock baselines or parallel OpenAI threads on custom product datasets.</a:t>
-            </a:r>
-            <a:br/>
-            <a:r>
-              <a:t>• [4] Auto-Prompt Optimizer: Self-tuning loop to dynamically fix prompt instructions based on failure sets.</a:t>
-            </a:r>
-            <a:br/>
-            <a:r>
-              <a:t>• [5] Visual side-by-side Prompt Diff: Instantly review optimized vs baseline guidelines via diff_prompts.py.</a:t>
-            </a:r>
-            <a:br/>
-            <a:r>
-              <a:t>• [6-7] Presentations &amp; Reports: Auto-generate visual browser dashboards (training_runs_report.md) &amp; slides.</a:t>
-            </a:r>
-            <a:br/>
-            <a:r>
-              <a:t>• [9] Saved Pipeline Summaries: Quickly fetch local summaries (evaluation_report_summary.txt).</a:t>
-            </a:r>
-          </a:p>
-        </p:txBody>
-      </p:sp>
-    </p:spTree>
-  </p:cSld>
-  <p:clrMapOvr>
-    <a:masterClrMapping/>
-  </p:clrMapOvr>
-</p:sld>
-</file>
-
-<file path=ppt/slides/slide8.xml><?xml version="1.0" encoding="utf-8"?>
-<p:sld xmlns:a="http://schemas.openxmlformats.org/drawingml/2006/main" xmlns:p="http://schemas.openxmlformats.org/presentationml/2006/main" xmlns:r="http://schemas.openxmlformats.org/officeDocument/2006/relationships">
-  <p:cSld>
-    <p:bg>
-      <p:bgPr>
-        <a:solidFill>
-          <a:srgbClr val="0A2240"/>
-        </a:solidFill>
-        <a:effectLst/>
-      </p:bgPr>
-    </p:bg>
-    <p:spTree>
-      <p:nvGrpSpPr>
-        <p:cNvPr id="1" name=""/>
-        <p:cNvGrpSpPr/>
-        <p:nvPr/>
-      </p:nvGrpSpPr>
-      <p:grpSpPr/>
-      <p:sp>
-        <p:nvSpPr>
-          <p:cNvPr id="2" name="TextBox 1"/>
-          <p:cNvSpPr txBox="1"/>
-          <p:nvPr/>
-        </p:nvSpPr>
-        <p:spPr>
-          <a:xfrm>
-            <a:off x="685800" y="274320"/>
-            <a:ext cx="10820095" cy="274320"/>
-          </a:xfrm>
-          <a:prstGeom prst="rect">
-            <a:avLst/>
-          </a:prstGeom>
-          <a:noFill/>
-        </p:spPr>
-        <p:txBody>
-          <a:bodyPr wrap="square" tIns="0" bIns="0" lIns="0">
-            <a:spAutoFit/>
-          </a:bodyPr>
-          <a:lstStyle/>
-          <a:p>
-            <a:pPr>
-              <a:defRPr sz="1000" b="1">
-                <a:solidFill>
-                  <a:srgbClr val="00A8B5"/>
-                </a:solidFill>
-                <a:latin typeface="Arial"/>
-              </a:defRPr>
-            </a:pPr>
-            <a:r>
-              <a:t>VERTEX SMART CATEGORIZATION ENGINE</a:t>
-            </a:r>
-          </a:p>
-        </p:txBody>
-      </p:sp>
-      <p:sp>
-        <p:nvSpPr>
-          <p:cNvPr id="3" name="TextBox 2"/>
-          <p:cNvSpPr txBox="1"/>
-          <p:nvPr/>
-        </p:nvSpPr>
-        <p:spPr>
-          <a:xfrm>
-            <a:off x="685800" y="457200"/>
-            <a:ext cx="10820095" cy="731520"/>
-          </a:xfrm>
-          <a:prstGeom prst="rect">
-            <a:avLst/>
-          </a:prstGeom>
-          <a:noFill/>
-        </p:spPr>
-        <p:txBody>
-          <a:bodyPr wrap="square" tIns="0" bIns="0" lIns="0">
-            <a:spAutoFit/>
-          </a:bodyPr>
-          <a:lstStyle/>
-          <a:p>
-            <a:pPr>
-              <a:defRPr sz="2800" b="1">
-                <a:solidFill>
-                  <a:srgbClr val="FFFFFF"/>
-                </a:solidFill>
-                <a:latin typeface="Arial"/>
-              </a:defRPr>
-            </a:pPr>
-            <a:r>
-              <a:t>Operational Impact &amp; Roadmap</a:t>
-            </a:r>
-          </a:p>
-        </p:txBody>
-      </p:sp>
-      <p:sp>
-        <p:nvSpPr>
-          <p:cNvPr id="4" name="Rectangle 3"/>
+              <a:defRPr sz="1200">
+                <a:solidFill>
+                  <a:srgbClr val="646973"/>
+                </a:solidFill>
+                <a:latin typeface="Calibri"/>
+              </a:defRPr>
+            </a:pPr>
+            <a:r>
+              <a:t>GPT-4o-mini achieves &gt;91.36% Precision and &gt;83% precision-weighted F0.5-score with optimized, structured prompt rules.</a:t>
+            </a:r>
+          </a:p>
+          <a:p>
+            <a:pPr>
+              <a:defRPr b="1" sz="1350">
+                <a:solidFill>
+                  <a:srgbClr val="0F2043"/>
+                </a:solidFill>
+                <a:latin typeface="Calibri"/>
+              </a:defRPr>
+            </a:pPr>
+            <a:r>
+              <a:t>High Throughput Execution</a:t>
+            </a:r>
+          </a:p>
+          <a:p>
+            <a:pPr>
+              <a:spcAft>
+                <a:spcPts val="1200"/>
+              </a:spcAft>
+              <a:defRPr sz="1200">
+                <a:solidFill>
+                  <a:srgbClr val="646973"/>
+                </a:solidFill>
+                <a:latin typeface="Calibri"/>
+              </a:defRPr>
+            </a:pPr>
+            <a:r>
+              <a:t>Highly parallelized processing threads classify 100k customer products in under 5 minutes.</a:t>
+            </a:r>
+          </a:p>
+          <a:p>
+            <a:pPr>
+              <a:defRPr b="1" sz="1350">
+                <a:solidFill>
+                  <a:srgbClr val="0F2043"/>
+                </a:solidFill>
+                <a:latin typeface="Calibri"/>
+              </a:defRPr>
+            </a:pPr>
+            <a:r>
+              <a:t>Cost Efficiency</a:t>
+            </a:r>
+          </a:p>
+          <a:p>
+            <a:pPr>
+              <a:defRPr sz="1200">
+                <a:solidFill>
+                  <a:srgbClr val="646973"/>
+                </a:solidFill>
+                <a:latin typeface="Calibri"/>
+              </a:defRPr>
+            </a:pPr>
+            <a:r>
+              <a:t>Extremely affordable run costs: ~$0.05 per 100 products ($50.00 total for 100k products).</a:t>
+            </a:r>
+          </a:p>
+        </p:txBody>
+      </p:sp>
+      <p:sp>
+        <p:nvSpPr>
+          <p:cNvPr id="6" name="Rounded Rectangle 5"/>
           <p:cNvSpPr/>
           <p:nvPr/>
         </p:nvSpPr>
         <p:spPr>
           <a:xfrm>
-            <a:off x="685800" y="1188720"/>
-            <a:ext cx="1828800" cy="36576"/>
-          </a:xfrm>
-          <a:prstGeom prst="rect">
+            <a:off x="6309360" y="1463040"/>
+            <a:ext cx="5120640" cy="4389120"/>
+          </a:xfrm>
+          <a:prstGeom prst="roundRect">
             <a:avLst/>
           </a:prstGeom>
           <a:solidFill>
-            <a:srgbClr val="00A8B5"/>
+            <a:srgbClr val="F8F9FC"/>
           </a:solidFill>
-          <a:ln>
-            <a:noFill/>
+          <a:ln w="6350">
+            <a:solidFill>
+              <a:srgbClr val="E1E4EB"/>
+            </a:solidFill>
           </a:ln>
         </p:spPr>
         <p:style>
@@ -6260,101 +6137,13 @@
       </p:sp>
       <p:sp>
         <p:nvSpPr>
-          <p:cNvPr id="5" name="Rectangle 4"/>
-          <p:cNvSpPr/>
-          <p:nvPr/>
-        </p:nvSpPr>
-        <p:spPr>
-          <a:xfrm>
-            <a:off x="0" y="0"/>
-            <a:ext cx="137160" cy="6858000"/>
-          </a:xfrm>
-          <a:prstGeom prst="rect">
-            <a:avLst/>
-          </a:prstGeom>
-          <a:solidFill>
-            <a:srgbClr val="00A8B5"/>
-          </a:solidFill>
-          <a:ln>
-            <a:noFill/>
-          </a:ln>
-        </p:spPr>
-        <p:style>
-          <a:lnRef idx="1">
-            <a:schemeClr val="accent1"/>
-          </a:lnRef>
-          <a:fillRef idx="3">
-            <a:schemeClr val="accent1"/>
-          </a:fillRef>
-          <a:effectRef idx="2">
-            <a:schemeClr val="accent1"/>
-          </a:effectRef>
-          <a:fontRef idx="minor">
-            <a:schemeClr val="lt1"/>
-          </a:fontRef>
-        </p:style>
-        <p:txBody>
-          <a:bodyPr rtlCol="0" anchor="ctr"/>
-          <a:lstStyle/>
-          <a:p>
-            <a:pPr algn="ctr"/>
-          </a:p>
-        </p:txBody>
-      </p:sp>
-      <p:sp>
-        <p:nvSpPr>
-          <p:cNvPr id="6" name="Rounded Rectangle 5"/>
-          <p:cNvSpPr/>
-          <p:nvPr/>
-        </p:nvSpPr>
-        <p:spPr>
-          <a:xfrm>
-            <a:off x="685800" y="1463040"/>
-            <a:ext cx="5120640" cy="4389120"/>
-          </a:xfrm>
-          <a:prstGeom prst="roundRect">
-            <a:avLst/>
-          </a:prstGeom>
-          <a:solidFill>
-            <a:srgbClr val="14325A"/>
-          </a:solidFill>
-          <a:ln w="12700">
-            <a:solidFill>
-              <a:srgbClr val="00A8B5"/>
-            </a:solidFill>
-          </a:ln>
-        </p:spPr>
-        <p:style>
-          <a:lnRef idx="1">
-            <a:schemeClr val="accent1"/>
-          </a:lnRef>
-          <a:fillRef idx="3">
-            <a:schemeClr val="accent1"/>
-          </a:fillRef>
-          <a:effectRef idx="2">
-            <a:schemeClr val="accent1"/>
-          </a:effectRef>
-          <a:fontRef idx="minor">
-            <a:schemeClr val="lt1"/>
-          </a:fontRef>
-        </p:style>
-        <p:txBody>
-          <a:bodyPr rtlCol="0" anchor="ctr"/>
-          <a:lstStyle/>
-          <a:p>
-            <a:pPr algn="ctr"/>
-          </a:p>
-        </p:txBody>
-      </p:sp>
-      <p:sp>
-        <p:nvSpPr>
           <p:cNvPr id="7" name="TextBox 6"/>
           <p:cNvSpPr txBox="1"/>
           <p:nvPr/>
         </p:nvSpPr>
         <p:spPr>
           <a:xfrm>
-            <a:off x="868680" y="1645920"/>
+            <a:off x="6492240" y="1645920"/>
             <a:ext cx="4754880" cy="4023360"/>
           </a:xfrm>
           <a:prstGeom prst="rect">
@@ -6372,185 +6161,24 @@
               <a:spcAft>
                 <a:spcPts val="1200"/>
               </a:spcAft>
-              <a:defRPr sz="1200" b="1">
-                <a:solidFill>
-                  <a:srgbClr val="00A8B5"/>
-                </a:solidFill>
-                <a:latin typeface="Arial"/>
-              </a:defRPr>
-            </a:pPr>
-            <a:r>
-              <a:t>EXPECTED OPERATIONAL PERFORMANCE</a:t>
+              <a:defRPr sz="1300" b="1">
+                <a:solidFill>
+                  <a:srgbClr val="007382"/>
+                </a:solidFill>
+                <a:latin typeface="Calibri"/>
+              </a:defRPr>
+            </a:pPr>
+            <a:r>
+              <a:t>PRODUCT ROADMAP &amp; NEXT STEPS</a:t>
             </a:r>
           </a:p>
           <a:p>
             <a:pPr>
               <a:defRPr b="1" sz="1300">
                 <a:solidFill>
-                  <a:srgbClr val="FFFFFF"/>
-                </a:solidFill>
-              </a:defRPr>
-            </a:pPr>
-            <a:r>
-              <a:t>🎯 Accuracy &amp; Confidence</a:t>
-            </a:r>
-          </a:p>
-          <a:p>
-            <a:pPr>
-              <a:spcAft>
-                <a:spcPts val="1200"/>
-              </a:spcAft>
-              <a:defRPr sz="1150">
-                <a:solidFill>
-                  <a:srgbClr val="AAB9CD"/>
-                </a:solidFill>
-              </a:defRPr>
-            </a:pPr>
-            <a:r>
-              <a:t>GPT-4o-mini achieves &gt;91.36% Precision and &gt;83% precision-weighted F0.5-score with optimized, structured prompt rules.</a:t>
-            </a:r>
-          </a:p>
-          <a:p>
-            <a:pPr>
-              <a:defRPr b="1" sz="1300">
-                <a:solidFill>
-                  <a:srgbClr val="FFFFFF"/>
-                </a:solidFill>
-              </a:defRPr>
-            </a:pPr>
-            <a:r>
-              <a:t>⚡ High Throughput Execution</a:t>
-            </a:r>
-          </a:p>
-          <a:p>
-            <a:pPr>
-              <a:spcAft>
-                <a:spcPts val="1200"/>
-              </a:spcAft>
-              <a:defRPr sz="1150">
-                <a:solidFill>
-                  <a:srgbClr val="AAB9CD"/>
-                </a:solidFill>
-              </a:defRPr>
-            </a:pPr>
-            <a:r>
-              <a:t>Highly parallelized processing threads classify 100k customer products in under 5 minutes.</a:t>
-            </a:r>
-          </a:p>
-          <a:p>
-            <a:pPr>
-              <a:defRPr b="1" sz="1300">
-                <a:solidFill>
-                  <a:srgbClr val="FFFFFF"/>
-                </a:solidFill>
-              </a:defRPr>
-            </a:pPr>
-            <a:r>
-              <a:t>💵 Cost Efficiency</a:t>
-            </a:r>
-          </a:p>
-          <a:p>
-            <a:pPr>
-              <a:defRPr sz="1150">
-                <a:solidFill>
-                  <a:srgbClr val="AAB9CD"/>
-                </a:solidFill>
-              </a:defRPr>
-            </a:pPr>
-            <a:r>
-              <a:t>Extremely affordable run costs: ~$0.05 per 100 products ($50.00 total for 100k products).</a:t>
-            </a:r>
-          </a:p>
-        </p:txBody>
-      </p:sp>
-      <p:sp>
-        <p:nvSpPr>
-          <p:cNvPr id="8" name="Rounded Rectangle 7"/>
-          <p:cNvSpPr/>
-          <p:nvPr/>
-        </p:nvSpPr>
-        <p:spPr>
-          <a:xfrm>
-            <a:off x="6385255" y="1463040"/>
-            <a:ext cx="5120640" cy="4389120"/>
-          </a:xfrm>
-          <a:prstGeom prst="roundRect">
-            <a:avLst/>
-          </a:prstGeom>
-          <a:solidFill>
-            <a:srgbClr val="14325A"/>
-          </a:solidFill>
-          <a:ln w="6350">
-            <a:solidFill>
-              <a:srgbClr val="DCE1E6"/>
-            </a:solidFill>
-          </a:ln>
-        </p:spPr>
-        <p:style>
-          <a:lnRef idx="1">
-            <a:schemeClr val="accent1"/>
-          </a:lnRef>
-          <a:fillRef idx="3">
-            <a:schemeClr val="accent1"/>
-          </a:fillRef>
-          <a:effectRef idx="2">
-            <a:schemeClr val="accent1"/>
-          </a:effectRef>
-          <a:fontRef idx="minor">
-            <a:schemeClr val="lt1"/>
-          </a:fontRef>
-        </p:style>
-        <p:txBody>
-          <a:bodyPr rtlCol="0" anchor="ctr"/>
-          <a:lstStyle/>
-          <a:p>
-            <a:pPr algn="ctr"/>
-          </a:p>
-        </p:txBody>
-      </p:sp>
-      <p:sp>
-        <p:nvSpPr>
-          <p:cNvPr id="9" name="TextBox 8"/>
-          <p:cNvSpPr txBox="1"/>
-          <p:nvPr/>
-        </p:nvSpPr>
-        <p:spPr>
-          <a:xfrm>
-            <a:off x="6568135" y="1645920"/>
-            <a:ext cx="4754880" cy="4023360"/>
-          </a:xfrm>
-          <a:prstGeom prst="rect">
-            <a:avLst/>
-          </a:prstGeom>
-          <a:noFill/>
-        </p:spPr>
-        <p:txBody>
-          <a:bodyPr wrap="square">
-            <a:spAutoFit/>
-          </a:bodyPr>
-          <a:lstStyle/>
-          <a:p>
-            <a:pPr>
-              <a:spcAft>
-                <a:spcPts val="1200"/>
-              </a:spcAft>
-              <a:defRPr sz="1200" b="1">
-                <a:solidFill>
-                  <a:srgbClr val="00A8B5"/>
-                </a:solidFill>
-                <a:latin typeface="Arial"/>
-              </a:defRPr>
-            </a:pPr>
-            <a:r>
-              <a:t>PRODUCT ROADMAP &amp; NEXT STEPS</a:t>
-            </a:r>
-          </a:p>
-          <a:p>
-            <a:pPr>
-              <a:defRPr b="1" sz="1250">
-                <a:solidFill>
-                  <a:srgbClr val="FFFFFF"/>
-                </a:solidFill>
+                  <a:srgbClr val="0F2043"/>
+                </a:solidFill>
+                <a:latin typeface="Calibri"/>
               </a:defRPr>
             </a:pPr>
             <a:r>
@@ -6562,10 +6190,11 @@
               <a:spcAft>
                 <a:spcPts val="800"/>
               </a:spcAft>
-              <a:defRPr sz="1100">
-                <a:solidFill>
-                  <a:srgbClr val="AAB9CD"/>
-                </a:solidFill>
+              <a:defRPr sz="1150">
+                <a:solidFill>
+                  <a:srgbClr val="646973"/>
+                </a:solidFill>
+                <a:latin typeface="Calibri"/>
               </a:defRPr>
             </a:pPr>
             <a:r>
@@ -6574,10 +6203,11 @@
           </a:p>
           <a:p>
             <a:pPr>
-              <a:defRPr b="1" sz="1250">
-                <a:solidFill>
-                  <a:srgbClr val="FFFFFF"/>
-                </a:solidFill>
+              <a:defRPr b="1" sz="1300">
+                <a:solidFill>
+                  <a:srgbClr val="0F2043"/>
+                </a:solidFill>
+                <a:latin typeface="Calibri"/>
               </a:defRPr>
             </a:pPr>
             <a:r>
@@ -6589,10 +6219,11 @@
               <a:spcAft>
                 <a:spcPts val="800"/>
               </a:spcAft>
-              <a:defRPr sz="1100">
-                <a:solidFill>
-                  <a:srgbClr val="AAB9CD"/>
-                </a:solidFill>
+              <a:defRPr sz="1150">
+                <a:solidFill>
+                  <a:srgbClr val="646973"/>
+                </a:solidFill>
+                <a:latin typeface="Calibri"/>
               </a:defRPr>
             </a:pPr>
             <a:r>
@@ -6601,10 +6232,11 @@
           </a:p>
           <a:p>
             <a:pPr>
-              <a:defRPr b="1" sz="1250">
-                <a:solidFill>
-                  <a:srgbClr val="FFFFFF"/>
-                </a:solidFill>
+              <a:defRPr b="1" sz="1300">
+                <a:solidFill>
+                  <a:srgbClr val="0F2043"/>
+                </a:solidFill>
+                <a:latin typeface="Calibri"/>
               </a:defRPr>
             </a:pPr>
             <a:r>
@@ -6616,10 +6248,11 @@
               <a:spcAft>
                 <a:spcPts val="800"/>
               </a:spcAft>
-              <a:defRPr sz="1100">
-                <a:solidFill>
-                  <a:srgbClr val="AAB9CD"/>
-                </a:solidFill>
+              <a:defRPr sz="1150">
+                <a:solidFill>
+                  <a:srgbClr val="646973"/>
+                </a:solidFill>
+                <a:latin typeface="Calibri"/>
               </a:defRPr>
             </a:pPr>
             <a:r>
@@ -6628,10 +6261,11 @@
           </a:p>
           <a:p>
             <a:pPr>
-              <a:defRPr b="1" sz="1250">
-                <a:solidFill>
-                  <a:srgbClr val="FFFFFF"/>
-                </a:solidFill>
+              <a:defRPr b="1" sz="1300">
+                <a:solidFill>
+                  <a:srgbClr val="0F2043"/>
+                </a:solidFill>
+                <a:latin typeface="Calibri"/>
               </a:defRPr>
             </a:pPr>
             <a:r>
@@ -6640,10 +6274,11 @@
           </a:p>
           <a:p>
             <a:pPr>
-              <a:defRPr sz="1100">
-                <a:solidFill>
-                  <a:srgbClr val="AAB9CD"/>
-                </a:solidFill>
+              <a:defRPr sz="1150">
+                <a:solidFill>
+                  <a:srgbClr val="646973"/>
+                </a:solidFill>
+                <a:latin typeface="Calibri"/>
               </a:defRPr>
             </a:pPr>
             <a:r>

</xml_diff>